<commit_message>
Made functions for Octave
</commit_message>
<xml_diff>
--- a/Results Notes/HeLA - 20260908.pptx
+++ b/Results Notes/HeLA - 20260908.pptx
@@ -13,7 +13,8 @@
     <p:sldId id="262" r:id="rId7"/>
     <p:sldId id="261" r:id="rId8"/>
     <p:sldId id="264" r:id="rId9"/>
-    <p:sldId id="263" r:id="rId10"/>
+    <p:sldId id="265" r:id="rId10"/>
+    <p:sldId id="263" r:id="rId11"/>
   </p:sldIdLst>
   <p:sldSz cx="12192000" cy="6858000"/>
   <p:notesSz cx="6858000" cy="9144000"/>
@@ -269,7 +270,7 @@
           <a:p>
             <a:fld id="{4C3E5437-416D-401B-AE6C-C07CB4A479CF}" type="datetimeFigureOut">
               <a:rPr lang="en-GB" smtClean="0"/>
-              <a:t>23/09/2026</a:t>
+              <a:t>08/10/2026</a:t>
             </a:fld>
             <a:endParaRPr lang="en-GB"/>
           </a:p>
@@ -469,7 +470,7 @@
           <a:p>
             <a:fld id="{4C3E5437-416D-401B-AE6C-C07CB4A479CF}" type="datetimeFigureOut">
               <a:rPr lang="en-GB" smtClean="0"/>
-              <a:t>23/09/2026</a:t>
+              <a:t>08/10/2026</a:t>
             </a:fld>
             <a:endParaRPr lang="en-GB"/>
           </a:p>
@@ -679,7 +680,7 @@
           <a:p>
             <a:fld id="{4C3E5437-416D-401B-AE6C-C07CB4A479CF}" type="datetimeFigureOut">
               <a:rPr lang="en-GB" smtClean="0"/>
-              <a:t>23/09/2026</a:t>
+              <a:t>08/10/2026</a:t>
             </a:fld>
             <a:endParaRPr lang="en-GB"/>
           </a:p>
@@ -879,7 +880,7 @@
           <a:p>
             <a:fld id="{4C3E5437-416D-401B-AE6C-C07CB4A479CF}" type="datetimeFigureOut">
               <a:rPr lang="en-GB" smtClean="0"/>
-              <a:t>23/09/2026</a:t>
+              <a:t>08/10/2026</a:t>
             </a:fld>
             <a:endParaRPr lang="en-GB"/>
           </a:p>
@@ -1155,7 +1156,7 @@
           <a:p>
             <a:fld id="{4C3E5437-416D-401B-AE6C-C07CB4A479CF}" type="datetimeFigureOut">
               <a:rPr lang="en-GB" smtClean="0"/>
-              <a:t>23/09/2026</a:t>
+              <a:t>08/10/2026</a:t>
             </a:fld>
             <a:endParaRPr lang="en-GB"/>
           </a:p>
@@ -1423,7 +1424,7 @@
           <a:p>
             <a:fld id="{4C3E5437-416D-401B-AE6C-C07CB4A479CF}" type="datetimeFigureOut">
               <a:rPr lang="en-GB" smtClean="0"/>
-              <a:t>23/09/2026</a:t>
+              <a:t>08/10/2026</a:t>
             </a:fld>
             <a:endParaRPr lang="en-GB"/>
           </a:p>
@@ -1838,7 +1839,7 @@
           <a:p>
             <a:fld id="{4C3E5437-416D-401B-AE6C-C07CB4A479CF}" type="datetimeFigureOut">
               <a:rPr lang="en-GB" smtClean="0"/>
-              <a:t>23/09/2026</a:t>
+              <a:t>08/10/2026</a:t>
             </a:fld>
             <a:endParaRPr lang="en-GB"/>
           </a:p>
@@ -1980,7 +1981,7 @@
           <a:p>
             <a:fld id="{4C3E5437-416D-401B-AE6C-C07CB4A479CF}" type="datetimeFigureOut">
               <a:rPr lang="en-GB" smtClean="0"/>
-              <a:t>23/09/2026</a:t>
+              <a:t>08/10/2026</a:t>
             </a:fld>
             <a:endParaRPr lang="en-GB"/>
           </a:p>
@@ -2093,7 +2094,7 @@
           <a:p>
             <a:fld id="{4C3E5437-416D-401B-AE6C-C07CB4A479CF}" type="datetimeFigureOut">
               <a:rPr lang="en-GB" smtClean="0"/>
-              <a:t>23/09/2026</a:t>
+              <a:t>08/10/2026</a:t>
             </a:fld>
             <a:endParaRPr lang="en-GB"/>
           </a:p>
@@ -2406,7 +2407,7 @@
           <a:p>
             <a:fld id="{4C3E5437-416D-401B-AE6C-C07CB4A479CF}" type="datetimeFigureOut">
               <a:rPr lang="en-GB" smtClean="0"/>
-              <a:t>23/09/2026</a:t>
+              <a:t>08/10/2026</a:t>
             </a:fld>
             <a:endParaRPr lang="en-GB"/>
           </a:p>
@@ -2695,7 +2696,7 @@
           <a:p>
             <a:fld id="{4C3E5437-416D-401B-AE6C-C07CB4A479CF}" type="datetimeFigureOut">
               <a:rPr lang="en-GB" smtClean="0"/>
-              <a:t>23/09/2026</a:t>
+              <a:t>08/10/2026</a:t>
             </a:fld>
             <a:endParaRPr lang="en-GB"/>
           </a:p>
@@ -2938,7 +2939,7 @@
           <a:p>
             <a:fld id="{4C3E5437-416D-401B-AE6C-C07CB4A479CF}" type="datetimeFigureOut">
               <a:rPr lang="en-GB" smtClean="0"/>
-              <a:t>23/09/2026</a:t>
+              <a:t>08/10/2026</a:t>
             </a:fld>
             <a:endParaRPr lang="en-GB"/>
           </a:p>
@@ -3398,6 +3399,1123 @@
 </p:sld>
 </file>
 
+<file path=ppt/slides/slide10.xml><?xml version="1.0" encoding="utf-8"?>
+<p:sld xmlns:a="http://schemas.openxmlformats.org/drawingml/2006/main" xmlns:r="http://schemas.openxmlformats.org/officeDocument/2006/relationships" xmlns:p="http://schemas.openxmlformats.org/presentationml/2006/main" show="0">
+  <p:cSld>
+    <p:spTree>
+      <p:nvGrpSpPr>
+        <p:cNvPr id="1" name=""/>
+        <p:cNvGrpSpPr/>
+        <p:nvPr/>
+      </p:nvGrpSpPr>
+      <p:grpSpPr>
+        <a:xfrm>
+          <a:off x="0" y="0"/>
+          <a:ext cx="0" cy="0"/>
+          <a:chOff x="0" y="0"/>
+          <a:chExt cx="0" cy="0"/>
+        </a:xfrm>
+      </p:grpSpPr>
+      <p:sp>
+        <p:nvSpPr>
+          <p:cNvPr id="2" name="Title 1">
+            <a:extLst>
+              <a:ext uri="{FF2B5EF4-FFF2-40B4-BE49-F238E27FC236}">
+                <a16:creationId xmlns:a16="http://schemas.microsoft.com/office/drawing/2014/main" id="{67841D5E-3956-1F1B-CB0C-100ECBCF637A}"/>
+              </a:ext>
+            </a:extLst>
+          </p:cNvPr>
+          <p:cNvSpPr>
+            <a:spLocks noGrp="1"/>
+          </p:cNvSpPr>
+          <p:nvPr>
+            <p:ph type="title"/>
+          </p:nvPr>
+        </p:nvSpPr>
+        <p:spPr/>
+        <p:txBody>
+          <a:bodyPr/>
+          <a:lstStyle/>
+          <a:p>
+            <a:r>
+              <a:rPr lang="en-GB" dirty="0"/>
+              <a:t>Flagged Features</a:t>
+            </a:r>
+          </a:p>
+        </p:txBody>
+      </p:sp>
+      <p:graphicFrame>
+        <p:nvGraphicFramePr>
+          <p:cNvPr id="10" name="Table 9">
+            <a:extLst>
+              <a:ext uri="{FF2B5EF4-FFF2-40B4-BE49-F238E27FC236}">
+                <a16:creationId xmlns:a16="http://schemas.microsoft.com/office/drawing/2014/main" id="{D82D070E-CF95-1F9C-4A0E-419CC37B51AC}"/>
+              </a:ext>
+            </a:extLst>
+          </p:cNvPr>
+          <p:cNvGraphicFramePr>
+            <a:graphicFrameLocks noGrp="1"/>
+          </p:cNvGraphicFramePr>
+          <p:nvPr>
+            <p:extLst>
+              <p:ext uri="{D42A27DB-BD31-4B8C-83A1-F6EECF244321}">
+                <p14:modId xmlns:p14="http://schemas.microsoft.com/office/powerpoint/2010/main" val="1722684761"/>
+              </p:ext>
+            </p:extLst>
+          </p:nvPr>
+        </p:nvGraphicFramePr>
+        <p:xfrm>
+          <a:off x="12000" y="1527858"/>
+          <a:ext cx="12168000" cy="5217035"/>
+        </p:xfrm>
+        <a:graphic>
+          <a:graphicData uri="http://schemas.openxmlformats.org/drawingml/2006/table">
+            <a:tbl>
+              <a:tblPr firstRow="1" bandRow="1">
+                <a:tableStyleId>{5C22544A-7EE6-4342-B048-85BDC9FD1C3A}</a:tableStyleId>
+              </a:tblPr>
+              <a:tblGrid>
+                <a:gridCol w="2880000">
+                  <a:extLst>
+                    <a:ext uri="{9D8B030D-6E8A-4147-A177-3AD203B41FA5}">
+                      <a16:colId xmlns:a16="http://schemas.microsoft.com/office/drawing/2014/main" val="908099444"/>
+                    </a:ext>
+                  </a:extLst>
+                </a:gridCol>
+                <a:gridCol w="684000">
+                  <a:extLst>
+                    <a:ext uri="{9D8B030D-6E8A-4147-A177-3AD203B41FA5}">
+                      <a16:colId xmlns:a16="http://schemas.microsoft.com/office/drawing/2014/main" val="304222866"/>
+                    </a:ext>
+                  </a:extLst>
+                </a:gridCol>
+                <a:gridCol w="3240000">
+                  <a:extLst>
+                    <a:ext uri="{9D8B030D-6E8A-4147-A177-3AD203B41FA5}">
+                      <a16:colId xmlns:a16="http://schemas.microsoft.com/office/drawing/2014/main" val="1931972079"/>
+                    </a:ext>
+                  </a:extLst>
+                </a:gridCol>
+                <a:gridCol w="684000">
+                  <a:extLst>
+                    <a:ext uri="{9D8B030D-6E8A-4147-A177-3AD203B41FA5}">
+                      <a16:colId xmlns:a16="http://schemas.microsoft.com/office/drawing/2014/main" val="3431500333"/>
+                    </a:ext>
+                  </a:extLst>
+                </a:gridCol>
+                <a:gridCol w="4680000">
+                  <a:extLst>
+                    <a:ext uri="{9D8B030D-6E8A-4147-A177-3AD203B41FA5}">
+                      <a16:colId xmlns:a16="http://schemas.microsoft.com/office/drawing/2014/main" val="4084811004"/>
+                    </a:ext>
+                  </a:extLst>
+                </a:gridCol>
+              </a:tblGrid>
+              <a:tr h="348127">
+                <a:tc>
+                  <a:txBody>
+                    <a:bodyPr/>
+                    <a:lstStyle/>
+                    <a:p>
+                      <a:pPr algn="ctr"/>
+                      <a:r>
+                        <a:rPr lang="en-GB" dirty="0"/>
+                        <a:t>Cell 01</a:t>
+                      </a:r>
+                    </a:p>
+                  </a:txBody>
+                  <a:tcPr anchor="ctr"/>
+                </a:tc>
+                <a:tc>
+                  <a:txBody>
+                    <a:bodyPr/>
+                    <a:lstStyle/>
+                    <a:p>
+                      <a:pPr algn="ctr"/>
+                      <a:r>
+                        <a:rPr lang="en-GB" dirty="0"/>
+                        <a:t>z</a:t>
+                      </a:r>
+                    </a:p>
+                  </a:txBody>
+                  <a:tcPr anchor="ctr"/>
+                </a:tc>
+                <a:tc>
+                  <a:txBody>
+                    <a:bodyPr/>
+                    <a:lstStyle/>
+                    <a:p>
+                      <a:pPr algn="ctr"/>
+                      <a:r>
+                        <a:rPr lang="en-GB" dirty="0"/>
+                        <a:t>Cell 02</a:t>
+                      </a:r>
+                    </a:p>
+                  </a:txBody>
+                  <a:tcPr anchor="ctr"/>
+                </a:tc>
+                <a:tc>
+                  <a:txBody>
+                    <a:bodyPr/>
+                    <a:lstStyle/>
+                    <a:p>
+                      <a:pPr algn="ctr"/>
+                      <a:r>
+                        <a:rPr lang="en-GB" dirty="0"/>
+                        <a:t>z</a:t>
+                      </a:r>
+                    </a:p>
+                  </a:txBody>
+                  <a:tcPr anchor="ctr"/>
+                </a:tc>
+                <a:tc>
+                  <a:txBody>
+                    <a:bodyPr/>
+                    <a:lstStyle/>
+                    <a:p>
+                      <a:pPr algn="ctr"/>
+                      <a:r>
+                        <a:rPr lang="en-GB" dirty="0"/>
+                        <a:t>Plain English</a:t>
+                      </a:r>
+                    </a:p>
+                  </a:txBody>
+                  <a:tcPr anchor="ctr">
+                    <a:solidFill>
+                      <a:schemeClr val="bg2">
+                        <a:lumMod val="25000"/>
+                      </a:schemeClr>
+                    </a:solidFill>
+                  </a:tcPr>
+                </a:tc>
+                <a:extLst>
+                  <a:ext uri="{0D108BD9-81ED-4DB2-BD59-A6C34878D82A}">
+                    <a16:rowId xmlns:a16="http://schemas.microsoft.com/office/drawing/2014/main" val="2315619706"/>
+                  </a:ext>
+                </a:extLst>
+              </a:tr>
+              <a:tr h="375020">
+                <a:tc>
+                  <a:txBody>
+                    <a:bodyPr/>
+                    <a:lstStyle/>
+                    <a:p>
+                      <a:pPr algn="ctr"/>
+                      <a:r>
+                        <a:rPr lang="en-GB" sz="1500" b="0" dirty="0"/>
+                        <a:t>nucleus_volume</a:t>
+                      </a:r>
+                    </a:p>
+                  </a:txBody>
+                  <a:tcPr anchor="ctr"/>
+                </a:tc>
+                <a:tc>
+                  <a:txBody>
+                    <a:bodyPr/>
+                    <a:lstStyle/>
+                    <a:p>
+                      <a:pPr algn="ctr"/>
+                      <a:r>
+                        <a:rPr lang="en-GB" sz="1500" b="0" dirty="0"/>
+                        <a:t>2.53</a:t>
+                      </a:r>
+                    </a:p>
+                  </a:txBody>
+                  <a:tcPr anchor="ctr"/>
+                </a:tc>
+                <a:tc>
+                  <a:txBody>
+                    <a:bodyPr/>
+                    <a:lstStyle/>
+                    <a:p>
+                      <a:pPr algn="ctr"/>
+                      <a:endParaRPr lang="en-GB" sz="1500" b="0" dirty="0"/>
+                    </a:p>
+                  </a:txBody>
+                  <a:tcPr anchor="ctr"/>
+                </a:tc>
+                <a:tc>
+                  <a:txBody>
+                    <a:bodyPr/>
+                    <a:lstStyle/>
+                    <a:p>
+                      <a:pPr algn="ctr"/>
+                      <a:endParaRPr lang="en-GB" sz="1500" b="0" dirty="0"/>
+                    </a:p>
+                  </a:txBody>
+                  <a:tcPr anchor="ctr"/>
+                </a:tc>
+                <a:tc>
+                  <a:txBody>
+                    <a:bodyPr/>
+                    <a:lstStyle/>
+                    <a:p>
+                      <a:pPr algn="ctr"/>
+                      <a:r>
+                        <a:rPr lang="en-GB" sz="1500" b="0" dirty="0"/>
+                        <a:t>Volume of the nucleus</a:t>
+                      </a:r>
+                    </a:p>
+                  </a:txBody>
+                  <a:tcPr anchor="ctr">
+                    <a:solidFill>
+                      <a:schemeClr val="bg2">
+                        <a:lumMod val="90000"/>
+                      </a:schemeClr>
+                    </a:solidFill>
+                  </a:tcPr>
+                </a:tc>
+                <a:extLst>
+                  <a:ext uri="{0D108BD9-81ED-4DB2-BD59-A6C34878D82A}">
+                    <a16:rowId xmlns:a16="http://schemas.microsoft.com/office/drawing/2014/main" val="2041569463"/>
+                  </a:ext>
+                </a:extLst>
+              </a:tr>
+              <a:tr h="348127">
+                <a:tc>
+                  <a:txBody>
+                    <a:bodyPr/>
+                    <a:lstStyle/>
+                    <a:p>
+                      <a:pPr algn="ctr"/>
+                      <a:r>
+                        <a:rPr lang="en-GB" sz="1500" b="1" dirty="0" err="1"/>
+                        <a:t>mitocloud_anisotropy</a:t>
+                      </a:r>
+                      <a:endParaRPr lang="en-GB" sz="1500" b="1" dirty="0"/>
+                    </a:p>
+                  </a:txBody>
+                  <a:tcPr anchor="ctr"/>
+                </a:tc>
+                <a:tc>
+                  <a:txBody>
+                    <a:bodyPr/>
+                    <a:lstStyle/>
+                    <a:p>
+                      <a:pPr algn="ctr"/>
+                      <a:r>
+                        <a:rPr lang="en-GB" sz="1500" b="1" dirty="0"/>
+                        <a:t>10.20</a:t>
+                      </a:r>
+                    </a:p>
+                  </a:txBody>
+                  <a:tcPr anchor="ctr"/>
+                </a:tc>
+                <a:tc>
+                  <a:txBody>
+                    <a:bodyPr/>
+                    <a:lstStyle/>
+                    <a:p>
+                      <a:pPr algn="ctr"/>
+                      <a:r>
+                        <a:rPr lang="en-GB" sz="1500" b="1" dirty="0" err="1"/>
+                        <a:t>mitocloud_anisotropy</a:t>
+                      </a:r>
+                      <a:endParaRPr lang="en-GB" sz="1500" b="1" dirty="0"/>
+                    </a:p>
+                  </a:txBody>
+                  <a:tcPr anchor="ctr"/>
+                </a:tc>
+                <a:tc>
+                  <a:txBody>
+                    <a:bodyPr/>
+                    <a:lstStyle/>
+                    <a:p>
+                      <a:pPr algn="ctr"/>
+                      <a:r>
+                        <a:rPr lang="en-GB" sz="1500" b="1" dirty="0"/>
+                        <a:t>4.50</a:t>
+                      </a:r>
+                    </a:p>
+                  </a:txBody>
+                  <a:tcPr anchor="ctr"/>
+                </a:tc>
+                <a:tc>
+                  <a:txBody>
+                    <a:bodyPr/>
+                    <a:lstStyle/>
+                    <a:p>
+                      <a:pPr algn="ctr"/>
+                      <a:r>
+                        <a:rPr lang="en-GB" sz="1500" b="0" dirty="0"/>
+                        <a:t>How elongated (like aspect ratio)</a:t>
+                      </a:r>
+                    </a:p>
+                  </a:txBody>
+                  <a:tcPr anchor="ctr">
+                    <a:solidFill>
+                      <a:schemeClr val="bg2"/>
+                    </a:solidFill>
+                  </a:tcPr>
+                </a:tc>
+                <a:extLst>
+                  <a:ext uri="{0D108BD9-81ED-4DB2-BD59-A6C34878D82A}">
+                    <a16:rowId xmlns:a16="http://schemas.microsoft.com/office/drawing/2014/main" val="3303511193"/>
+                  </a:ext>
+                </a:extLst>
+              </a:tr>
+              <a:tr h="480539">
+                <a:tc>
+                  <a:txBody>
+                    <a:bodyPr/>
+                    <a:lstStyle/>
+                    <a:p>
+                      <a:pPr algn="ctr"/>
+                      <a:r>
+                        <a:rPr lang="en-GB" sz="1500" b="0" dirty="0"/>
+                        <a:t>nucleus_mitocloud_L1</a:t>
+                      </a:r>
+                    </a:p>
+                  </a:txBody>
+                  <a:tcPr anchor="ctr"/>
+                </a:tc>
+                <a:tc>
+                  <a:txBody>
+                    <a:bodyPr/>
+                    <a:lstStyle/>
+                    <a:p>
+                      <a:pPr algn="ctr"/>
+                      <a:r>
+                        <a:rPr lang="en-GB" sz="1500" b="0" dirty="0"/>
+                        <a:t>7.41</a:t>
+                      </a:r>
+                    </a:p>
+                  </a:txBody>
+                  <a:tcPr anchor="ctr"/>
+                </a:tc>
+                <a:tc>
+                  <a:txBody>
+                    <a:bodyPr/>
+                    <a:lstStyle/>
+                    <a:p>
+                      <a:pPr algn="ctr"/>
+                      <a:r>
+                        <a:rPr lang="en-GB" sz="1500" b="0" dirty="0"/>
+                        <a:t>nucleus_mitocloud_L1</a:t>
+                      </a:r>
+                    </a:p>
+                  </a:txBody>
+                  <a:tcPr anchor="ctr"/>
+                </a:tc>
+                <a:tc>
+                  <a:txBody>
+                    <a:bodyPr/>
+                    <a:lstStyle/>
+                    <a:p>
+                      <a:pPr algn="ctr"/>
+                      <a:r>
+                        <a:rPr lang="en-GB" sz="1500" b="0" dirty="0"/>
+                        <a:t>5.19</a:t>
+                      </a:r>
+                    </a:p>
+                  </a:txBody>
+                  <a:tcPr anchor="ctr"/>
+                </a:tc>
+                <a:tc>
+                  <a:txBody>
+                    <a:bodyPr/>
+                    <a:lstStyle/>
+                    <a:p>
+                      <a:pPr algn="ctr"/>
+                      <a:r>
+                        <a:rPr lang="en-GB" sz="1500" b="0" dirty="0"/>
+                        <a:t>Spread along long axis</a:t>
+                      </a:r>
+                    </a:p>
+                  </a:txBody>
+                  <a:tcPr anchor="ctr">
+                    <a:solidFill>
+                      <a:schemeClr val="bg2">
+                        <a:lumMod val="90000"/>
+                      </a:schemeClr>
+                    </a:solidFill>
+                  </a:tcPr>
+                </a:tc>
+                <a:extLst>
+                  <a:ext uri="{0D108BD9-81ED-4DB2-BD59-A6C34878D82A}">
+                    <a16:rowId xmlns:a16="http://schemas.microsoft.com/office/drawing/2014/main" val="2110197775"/>
+                  </a:ext>
+                </a:extLst>
+              </a:tr>
+              <a:tr h="348127">
+                <a:tc>
+                  <a:txBody>
+                    <a:bodyPr/>
+                    <a:lstStyle/>
+                    <a:p>
+                      <a:pPr algn="ctr"/>
+                      <a:endParaRPr lang="en-GB" sz="1500" b="0" dirty="0"/>
+                    </a:p>
+                  </a:txBody>
+                  <a:tcPr anchor="ctr"/>
+                </a:tc>
+                <a:tc>
+                  <a:txBody>
+                    <a:bodyPr/>
+                    <a:lstStyle/>
+                    <a:p>
+                      <a:pPr algn="ctr"/>
+                      <a:endParaRPr lang="en-GB" sz="1500" b="0" dirty="0"/>
+                    </a:p>
+                  </a:txBody>
+                  <a:tcPr anchor="ctr"/>
+                </a:tc>
+                <a:tc>
+                  <a:txBody>
+                    <a:bodyPr/>
+                    <a:lstStyle/>
+                    <a:p>
+                      <a:pPr algn="ctr"/>
+                      <a:r>
+                        <a:rPr lang="en-GB" sz="1500" b="0" dirty="0"/>
+                        <a:t>nucleus_mitocloud_L2</a:t>
+                      </a:r>
+                    </a:p>
+                  </a:txBody>
+                  <a:tcPr anchor="ctr"/>
+                </a:tc>
+                <a:tc>
+                  <a:txBody>
+                    <a:bodyPr/>
+                    <a:lstStyle/>
+                    <a:p>
+                      <a:pPr algn="ctr"/>
+                      <a:r>
+                        <a:rPr lang="en-GB" sz="1500" b="0" dirty="0"/>
+                        <a:t>2.32</a:t>
+                      </a:r>
+                    </a:p>
+                  </a:txBody>
+                  <a:tcPr anchor="ctr"/>
+                </a:tc>
+                <a:tc>
+                  <a:txBody>
+                    <a:bodyPr/>
+                    <a:lstStyle/>
+                    <a:p>
+                      <a:pPr algn="ctr"/>
+                      <a:r>
+                        <a:rPr lang="en-GB" sz="1500" b="0" dirty="0"/>
+                        <a:t>Spread along mid axis</a:t>
+                      </a:r>
+                    </a:p>
+                  </a:txBody>
+                  <a:tcPr anchor="ctr">
+                    <a:solidFill>
+                      <a:schemeClr val="bg2"/>
+                    </a:solidFill>
+                  </a:tcPr>
+                </a:tc>
+                <a:extLst>
+                  <a:ext uri="{0D108BD9-81ED-4DB2-BD59-A6C34878D82A}">
+                    <a16:rowId xmlns:a16="http://schemas.microsoft.com/office/drawing/2014/main" val="4086284408"/>
+                  </a:ext>
+                </a:extLst>
+              </a:tr>
+              <a:tr h="348127">
+                <a:tc>
+                  <a:txBody>
+                    <a:bodyPr/>
+                    <a:lstStyle/>
+                    <a:p>
+                      <a:pPr algn="ctr"/>
+                      <a:endParaRPr lang="en-GB" sz="1500" b="0" dirty="0"/>
+                    </a:p>
+                  </a:txBody>
+                  <a:tcPr anchor="ctr"/>
+                </a:tc>
+                <a:tc>
+                  <a:txBody>
+                    <a:bodyPr/>
+                    <a:lstStyle/>
+                    <a:p>
+                      <a:pPr algn="ctr"/>
+                      <a:endParaRPr lang="en-GB" sz="1500" b="0" dirty="0"/>
+                    </a:p>
+                  </a:txBody>
+                  <a:tcPr anchor="ctr"/>
+                </a:tc>
+                <a:tc>
+                  <a:txBody>
+                    <a:bodyPr/>
+                    <a:lstStyle/>
+                    <a:p>
+                      <a:pPr algn="ctr"/>
+                      <a:r>
+                        <a:rPr lang="en-GB" sz="1500" b="0" dirty="0" err="1"/>
+                        <a:t>nucleus_distance_of_centroids</a:t>
+                      </a:r>
+                      <a:endParaRPr lang="en-GB" sz="1500" b="0" dirty="0"/>
+                    </a:p>
+                  </a:txBody>
+                  <a:tcPr anchor="ctr"/>
+                </a:tc>
+                <a:tc>
+                  <a:txBody>
+                    <a:bodyPr/>
+                    <a:lstStyle/>
+                    <a:p>
+                      <a:pPr algn="ctr"/>
+                      <a:r>
+                        <a:rPr lang="en-GB" sz="1500" b="0" dirty="0"/>
+                        <a:t>2.29</a:t>
+                      </a:r>
+                    </a:p>
+                  </a:txBody>
+                  <a:tcPr anchor="ctr"/>
+                </a:tc>
+                <a:tc>
+                  <a:txBody>
+                    <a:bodyPr/>
+                    <a:lstStyle/>
+                    <a:p>
+                      <a:pPr algn="ctr"/>
+                      <a:r>
+                        <a:rPr lang="en-GB" sz="1500" b="0" dirty="0"/>
+                        <a:t>Distance between </a:t>
+                      </a:r>
+                      <a:r>
+                        <a:rPr lang="en-GB" sz="1500" b="0" dirty="0" err="1"/>
+                        <a:t>nuc</a:t>
+                      </a:r>
+                      <a:r>
+                        <a:rPr lang="en-GB" sz="1500" b="0" dirty="0"/>
+                        <a:t> centroid and </a:t>
+                      </a:r>
+                      <a:r>
+                        <a:rPr lang="en-GB" sz="1500" b="0" dirty="0" err="1"/>
+                        <a:t>mitocloud</a:t>
+                      </a:r>
+                      <a:r>
+                        <a:rPr lang="en-GB" sz="1500" b="0" dirty="0"/>
+                        <a:t> centroid</a:t>
+                      </a:r>
+                    </a:p>
+                  </a:txBody>
+                  <a:tcPr anchor="ctr">
+                    <a:solidFill>
+                      <a:schemeClr val="bg2">
+                        <a:lumMod val="90000"/>
+                      </a:schemeClr>
+                    </a:solidFill>
+                  </a:tcPr>
+                </a:tc>
+                <a:extLst>
+                  <a:ext uri="{0D108BD9-81ED-4DB2-BD59-A6C34878D82A}">
+                    <a16:rowId xmlns:a16="http://schemas.microsoft.com/office/drawing/2014/main" val="3567486344"/>
+                  </a:ext>
+                </a:extLst>
+              </a:tr>
+              <a:tr h="348127">
+                <a:tc>
+                  <a:txBody>
+                    <a:bodyPr/>
+                    <a:lstStyle/>
+                    <a:p>
+                      <a:pPr algn="ctr"/>
+                      <a:r>
+                        <a:rPr lang="en-GB" sz="1500" b="0" dirty="0" err="1"/>
+                        <a:t>mito_volume_mean</a:t>
+                      </a:r>
+                      <a:endParaRPr lang="en-GB" sz="1500" b="0" dirty="0"/>
+                    </a:p>
+                  </a:txBody>
+                  <a:tcPr anchor="ctr"/>
+                </a:tc>
+                <a:tc>
+                  <a:txBody>
+                    <a:bodyPr/>
+                    <a:lstStyle/>
+                    <a:p>
+                      <a:pPr algn="ctr"/>
+                      <a:r>
+                        <a:rPr lang="en-GB" sz="1500" b="0" dirty="0"/>
+                        <a:t>-3.11</a:t>
+                      </a:r>
+                    </a:p>
+                  </a:txBody>
+                  <a:tcPr anchor="ctr"/>
+                </a:tc>
+                <a:tc>
+                  <a:txBody>
+                    <a:bodyPr/>
+                    <a:lstStyle/>
+                    <a:p>
+                      <a:pPr algn="ctr"/>
+                      <a:r>
+                        <a:rPr lang="en-GB" sz="1500" b="0" dirty="0"/>
+                        <a:t>mito_volume_mean</a:t>
+                      </a:r>
+                    </a:p>
+                  </a:txBody>
+                  <a:tcPr anchor="ctr"/>
+                </a:tc>
+                <a:tc>
+                  <a:txBody>
+                    <a:bodyPr/>
+                    <a:lstStyle/>
+                    <a:p>
+                      <a:pPr algn="ctr"/>
+                      <a:r>
+                        <a:rPr lang="en-GB" sz="1500" b="0" dirty="0"/>
+                        <a:t>-2.55</a:t>
+                      </a:r>
+                    </a:p>
+                  </a:txBody>
+                  <a:tcPr anchor="ctr"/>
+                </a:tc>
+                <a:tc>
+                  <a:txBody>
+                    <a:bodyPr/>
+                    <a:lstStyle/>
+                    <a:p>
+                      <a:pPr algn="ctr"/>
+                      <a:r>
+                        <a:rPr lang="en-GB" sz="1500" b="0" dirty="0"/>
+                        <a:t>Mean volume of mitochondria</a:t>
+                      </a:r>
+                    </a:p>
+                  </a:txBody>
+                  <a:tcPr anchor="ctr">
+                    <a:solidFill>
+                      <a:schemeClr val="bg2"/>
+                    </a:solidFill>
+                  </a:tcPr>
+                </a:tc>
+                <a:extLst>
+                  <a:ext uri="{0D108BD9-81ED-4DB2-BD59-A6C34878D82A}">
+                    <a16:rowId xmlns:a16="http://schemas.microsoft.com/office/drawing/2014/main" val="666761717"/>
+                  </a:ext>
+                </a:extLst>
+              </a:tr>
+              <a:tr h="480539">
+                <a:tc>
+                  <a:txBody>
+                    <a:bodyPr/>
+                    <a:lstStyle/>
+                    <a:p>
+                      <a:pPr algn="ctr"/>
+                      <a:endParaRPr lang="en-GB" sz="1500" b="0" dirty="0"/>
+                    </a:p>
+                  </a:txBody>
+                  <a:tcPr anchor="ctr"/>
+                </a:tc>
+                <a:tc>
+                  <a:txBody>
+                    <a:bodyPr/>
+                    <a:lstStyle/>
+                    <a:p>
+                      <a:pPr algn="ctr"/>
+                      <a:endParaRPr lang="en-GB" sz="1500" b="0" dirty="0"/>
+                    </a:p>
+                  </a:txBody>
+                  <a:tcPr anchor="ctr"/>
+                </a:tc>
+                <a:tc>
+                  <a:txBody>
+                    <a:bodyPr/>
+                    <a:lstStyle/>
+                    <a:p>
+                      <a:pPr algn="ctr"/>
+                      <a:r>
+                        <a:rPr lang="en-GB" sz="1500" b="0" dirty="0" err="1"/>
+                        <a:t>mito_volume_total</a:t>
+                      </a:r>
+                      <a:endParaRPr lang="en-GB" sz="1500" b="0" dirty="0"/>
+                    </a:p>
+                  </a:txBody>
+                  <a:tcPr anchor="ctr"/>
+                </a:tc>
+                <a:tc>
+                  <a:txBody>
+                    <a:bodyPr/>
+                    <a:lstStyle/>
+                    <a:p>
+                      <a:pPr algn="ctr"/>
+                      <a:r>
+                        <a:rPr lang="en-GB" sz="1500" b="0" dirty="0"/>
+                        <a:t>-2.55</a:t>
+                      </a:r>
+                    </a:p>
+                  </a:txBody>
+                  <a:tcPr anchor="ctr"/>
+                </a:tc>
+                <a:tc>
+                  <a:txBody>
+                    <a:bodyPr/>
+                    <a:lstStyle/>
+                    <a:p>
+                      <a:pPr algn="ctr"/>
+                      <a:r>
+                        <a:rPr lang="en-GB" sz="1500" b="0" dirty="0"/>
+                        <a:t>Total volume of all mitochondria</a:t>
+                      </a:r>
+                    </a:p>
+                  </a:txBody>
+                  <a:tcPr anchor="ctr">
+                    <a:solidFill>
+                      <a:schemeClr val="bg2">
+                        <a:lumMod val="90000"/>
+                      </a:schemeClr>
+                    </a:solidFill>
+                  </a:tcPr>
+                </a:tc>
+                <a:extLst>
+                  <a:ext uri="{0D108BD9-81ED-4DB2-BD59-A6C34878D82A}">
+                    <a16:rowId xmlns:a16="http://schemas.microsoft.com/office/drawing/2014/main" val="727758331"/>
+                  </a:ext>
+                </a:extLst>
+              </a:tr>
+              <a:tr h="480539">
+                <a:tc>
+                  <a:txBody>
+                    <a:bodyPr/>
+                    <a:lstStyle/>
+                    <a:p>
+                      <a:pPr algn="ctr"/>
+                      <a:r>
+                        <a:rPr lang="en-GB" sz="1500" b="1" dirty="0" err="1"/>
+                        <a:t>mito_surface_area_mean</a:t>
+                      </a:r>
+                      <a:endParaRPr lang="en-GB" sz="1500" b="1" dirty="0"/>
+                    </a:p>
+                  </a:txBody>
+                  <a:tcPr anchor="ctr"/>
+                </a:tc>
+                <a:tc>
+                  <a:txBody>
+                    <a:bodyPr/>
+                    <a:lstStyle/>
+                    <a:p>
+                      <a:pPr algn="ctr"/>
+                      <a:r>
+                        <a:rPr lang="en-GB" sz="1500" b="1" dirty="0"/>
+                        <a:t>-6.65</a:t>
+                      </a:r>
+                    </a:p>
+                  </a:txBody>
+                  <a:tcPr anchor="ctr"/>
+                </a:tc>
+                <a:tc>
+                  <a:txBody>
+                    <a:bodyPr/>
+                    <a:lstStyle/>
+                    <a:p>
+                      <a:pPr algn="ctr"/>
+                      <a:r>
+                        <a:rPr lang="en-GB" sz="1500" b="1" dirty="0"/>
+                        <a:t>mito_surface_area_mean</a:t>
+                      </a:r>
+                    </a:p>
+                  </a:txBody>
+                  <a:tcPr anchor="ctr"/>
+                </a:tc>
+                <a:tc>
+                  <a:txBody>
+                    <a:bodyPr/>
+                    <a:lstStyle/>
+                    <a:p>
+                      <a:pPr algn="ctr"/>
+                      <a:r>
+                        <a:rPr lang="en-GB" sz="1500" b="1" dirty="0"/>
+                        <a:t>-6.14</a:t>
+                      </a:r>
+                    </a:p>
+                  </a:txBody>
+                  <a:tcPr anchor="ctr"/>
+                </a:tc>
+                <a:tc>
+                  <a:txBody>
+                    <a:bodyPr/>
+                    <a:lstStyle/>
+                    <a:p>
+                      <a:pPr algn="ctr"/>
+                      <a:r>
+                        <a:rPr lang="en-GB" sz="1500" b="0" dirty="0"/>
+                        <a:t>Mean surf. area of mitochondria</a:t>
+                      </a:r>
+                    </a:p>
+                  </a:txBody>
+                  <a:tcPr anchor="ctr">
+                    <a:solidFill>
+                      <a:schemeClr val="bg2"/>
+                    </a:solidFill>
+                  </a:tcPr>
+                </a:tc>
+                <a:extLst>
+                  <a:ext uri="{0D108BD9-81ED-4DB2-BD59-A6C34878D82A}">
+                    <a16:rowId xmlns:a16="http://schemas.microsoft.com/office/drawing/2014/main" val="3410650873"/>
+                  </a:ext>
+                </a:extLst>
+              </a:tr>
+              <a:tr h="480539">
+                <a:tc>
+                  <a:txBody>
+                    <a:bodyPr/>
+                    <a:lstStyle/>
+                    <a:p>
+                      <a:pPr algn="ctr"/>
+                      <a:r>
+                        <a:rPr lang="en-GB" sz="1500" b="1" dirty="0"/>
+                        <a:t>mito_centroid_distance_mean</a:t>
+                      </a:r>
+                    </a:p>
+                  </a:txBody>
+                  <a:tcPr anchor="ctr"/>
+                </a:tc>
+                <a:tc>
+                  <a:txBody>
+                    <a:bodyPr/>
+                    <a:lstStyle/>
+                    <a:p>
+                      <a:pPr algn="ctr"/>
+                      <a:r>
+                        <a:rPr lang="en-GB" sz="1500" b="1" dirty="0"/>
+                        <a:t>4.75</a:t>
+                      </a:r>
+                    </a:p>
+                  </a:txBody>
+                  <a:tcPr anchor="ctr"/>
+                </a:tc>
+                <a:tc>
+                  <a:txBody>
+                    <a:bodyPr/>
+                    <a:lstStyle/>
+                    <a:p>
+                      <a:pPr algn="ctr"/>
+                      <a:r>
+                        <a:rPr lang="en-GB" sz="1500" b="1" dirty="0" err="1"/>
+                        <a:t>mito_centroid_distance_mean</a:t>
+                      </a:r>
+                      <a:endParaRPr lang="en-GB" sz="1500" b="1" dirty="0"/>
+                    </a:p>
+                  </a:txBody>
+                  <a:tcPr anchor="ctr"/>
+                </a:tc>
+                <a:tc>
+                  <a:txBody>
+                    <a:bodyPr/>
+                    <a:lstStyle/>
+                    <a:p>
+                      <a:pPr algn="ctr"/>
+                      <a:r>
+                        <a:rPr lang="en-GB" sz="1500" b="1" dirty="0"/>
+                        <a:t>4.19</a:t>
+                      </a:r>
+                    </a:p>
+                  </a:txBody>
+                  <a:tcPr anchor="ctr"/>
+                </a:tc>
+                <a:tc>
+                  <a:txBody>
+                    <a:bodyPr/>
+                    <a:lstStyle/>
+                    <a:p>
+                      <a:pPr algn="ctr"/>
+                      <a:r>
+                        <a:rPr lang="en-GB" sz="1500" b="0" dirty="0"/>
+                        <a:t>Mean mitochondria distance to nucleus centroid</a:t>
+                      </a:r>
+                    </a:p>
+                  </a:txBody>
+                  <a:tcPr anchor="ctr">
+                    <a:solidFill>
+                      <a:schemeClr val="bg2">
+                        <a:lumMod val="90000"/>
+                      </a:schemeClr>
+                    </a:solidFill>
+                  </a:tcPr>
+                </a:tc>
+                <a:extLst>
+                  <a:ext uri="{0D108BD9-81ED-4DB2-BD59-A6C34878D82A}">
+                    <a16:rowId xmlns:a16="http://schemas.microsoft.com/office/drawing/2014/main" val="3200666823"/>
+                  </a:ext>
+                </a:extLst>
+              </a:tr>
+              <a:tr h="480539">
+                <a:tc>
+                  <a:txBody>
+                    <a:bodyPr/>
+                    <a:lstStyle/>
+                    <a:p>
+                      <a:pPr algn="ctr"/>
+                      <a:r>
+                        <a:rPr lang="en-GB" sz="1500" b="1" dirty="0" err="1"/>
+                        <a:t>mito_surface_distance_mean</a:t>
+                      </a:r>
+                      <a:endParaRPr lang="en-GB" sz="1500" b="1" dirty="0"/>
+                    </a:p>
+                  </a:txBody>
+                  <a:tcPr anchor="ctr"/>
+                </a:tc>
+                <a:tc>
+                  <a:txBody>
+                    <a:bodyPr/>
+                    <a:lstStyle/>
+                    <a:p>
+                      <a:pPr algn="ctr"/>
+                      <a:r>
+                        <a:rPr lang="en-GB" sz="1500" b="1" dirty="0"/>
+                        <a:t>3.86</a:t>
+                      </a:r>
+                    </a:p>
+                  </a:txBody>
+                  <a:tcPr anchor="ctr"/>
+                </a:tc>
+                <a:tc>
+                  <a:txBody>
+                    <a:bodyPr/>
+                    <a:lstStyle/>
+                    <a:p>
+                      <a:pPr algn="ctr"/>
+                      <a:r>
+                        <a:rPr lang="en-GB" sz="1500" b="1" dirty="0" err="1"/>
+                        <a:t>mito_surface_distance_mean</a:t>
+                      </a:r>
+                      <a:endParaRPr lang="en-GB" sz="1500" b="1" dirty="0"/>
+                    </a:p>
+                  </a:txBody>
+                  <a:tcPr anchor="ctr"/>
+                </a:tc>
+                <a:tc>
+                  <a:txBody>
+                    <a:bodyPr/>
+                    <a:lstStyle/>
+                    <a:p>
+                      <a:pPr algn="ctr"/>
+                      <a:r>
+                        <a:rPr lang="en-GB" sz="1500" b="1" dirty="0"/>
+                        <a:t>4.39</a:t>
+                      </a:r>
+                    </a:p>
+                  </a:txBody>
+                  <a:tcPr anchor="ctr"/>
+                </a:tc>
+                <a:tc>
+                  <a:txBody>
+                    <a:bodyPr/>
+                    <a:lstStyle/>
+                    <a:p>
+                      <a:pPr algn="ctr"/>
+                      <a:r>
+                        <a:rPr lang="en-GB" sz="1500" b="0" dirty="0"/>
+                        <a:t>Mean mitochondria distance to nucleus surface</a:t>
+                      </a:r>
+                    </a:p>
+                  </a:txBody>
+                  <a:tcPr anchor="ctr">
+                    <a:solidFill>
+                      <a:schemeClr val="bg2"/>
+                    </a:solidFill>
+                  </a:tcPr>
+                </a:tc>
+                <a:extLst>
+                  <a:ext uri="{0D108BD9-81ED-4DB2-BD59-A6C34878D82A}">
+                    <a16:rowId xmlns:a16="http://schemas.microsoft.com/office/drawing/2014/main" val="190136355"/>
+                  </a:ext>
+                </a:extLst>
+              </a:tr>
+              <a:tr h="480539">
+                <a:tc>
+                  <a:txBody>
+                    <a:bodyPr/>
+                    <a:lstStyle/>
+                    <a:p>
+                      <a:pPr algn="ctr"/>
+                      <a:r>
+                        <a:rPr lang="en-GB" sz="1500" b="0" dirty="0"/>
+                        <a:t>mito_volume_fraction</a:t>
+                      </a:r>
+                    </a:p>
+                  </a:txBody>
+                  <a:tcPr anchor="ctr"/>
+                </a:tc>
+                <a:tc>
+                  <a:txBody>
+                    <a:bodyPr/>
+                    <a:lstStyle/>
+                    <a:p>
+                      <a:pPr algn="ctr"/>
+                      <a:r>
+                        <a:rPr lang="en-GB" sz="1500" b="0" dirty="0"/>
+                        <a:t>-3.27</a:t>
+                      </a:r>
+                    </a:p>
+                  </a:txBody>
+                  <a:tcPr anchor="ctr"/>
+                </a:tc>
+                <a:tc>
+                  <a:txBody>
+                    <a:bodyPr/>
+                    <a:lstStyle/>
+                    <a:p>
+                      <a:pPr algn="ctr"/>
+                      <a:r>
+                        <a:rPr lang="en-GB" sz="1500" b="0" dirty="0" err="1"/>
+                        <a:t>mito_volume_fraction</a:t>
+                      </a:r>
+                      <a:endParaRPr lang="en-GB" sz="1500" b="0" dirty="0"/>
+                    </a:p>
+                  </a:txBody>
+                  <a:tcPr anchor="ctr"/>
+                </a:tc>
+                <a:tc>
+                  <a:txBody>
+                    <a:bodyPr/>
+                    <a:lstStyle/>
+                    <a:p>
+                      <a:pPr algn="ctr"/>
+                      <a:r>
+                        <a:rPr lang="en-GB" sz="1500" b="0" dirty="0"/>
+                        <a:t>-3.53</a:t>
+                      </a:r>
+                    </a:p>
+                  </a:txBody>
+                  <a:tcPr anchor="ctr"/>
+                </a:tc>
+                <a:tc>
+                  <a:txBody>
+                    <a:bodyPr/>
+                    <a:lstStyle/>
+                    <a:p>
+                      <a:pPr algn="ctr"/>
+                      <a:r>
+                        <a:rPr lang="en-GB" sz="1500" b="0" dirty="0"/>
+                        <a:t>Ratio of mitochondrial volume to nuclear volume</a:t>
+                      </a:r>
+                    </a:p>
+                  </a:txBody>
+                  <a:tcPr anchor="ctr">
+                    <a:solidFill>
+                      <a:schemeClr val="bg2">
+                        <a:lumMod val="90000"/>
+                      </a:schemeClr>
+                    </a:solidFill>
+                  </a:tcPr>
+                </a:tc>
+                <a:extLst>
+                  <a:ext uri="{0D108BD9-81ED-4DB2-BD59-A6C34878D82A}">
+                    <a16:rowId xmlns:a16="http://schemas.microsoft.com/office/drawing/2014/main" val="1785511608"/>
+                  </a:ext>
+                </a:extLst>
+              </a:tr>
+            </a:tbl>
+          </a:graphicData>
+        </a:graphic>
+      </p:graphicFrame>
+    </p:spTree>
+    <p:extLst>
+      <p:ext uri="{BB962C8B-B14F-4D97-AF65-F5344CB8AC3E}">
+        <p14:creationId xmlns:p14="http://schemas.microsoft.com/office/powerpoint/2010/main" val="4292883916"/>
+      </p:ext>
+    </p:extLst>
+  </p:cSld>
+  <p:clrMapOvr>
+    <a:masterClrMapping/>
+  </p:clrMapOvr>
+</p:sld>
+</file>
+
 <file path=ppt/slides/slide2.xml><?xml version="1.0" encoding="utf-8"?>
 <p:sld xmlns:a="http://schemas.openxmlformats.org/drawingml/2006/main" xmlns:r="http://schemas.openxmlformats.org/officeDocument/2006/relationships" xmlns:p="http://schemas.openxmlformats.org/presentationml/2006/main">
   <p:cSld>
@@ -5521,7 +6639,13 @@
   <p:cSld>
     <p:spTree>
       <p:nvGrpSpPr>
-        <p:cNvPr id="1" name=""/>
+        <p:cNvPr id="1" name="">
+          <a:extLst>
+            <a:ext uri="{FF2B5EF4-FFF2-40B4-BE49-F238E27FC236}">
+              <a16:creationId xmlns:a16="http://schemas.microsoft.com/office/drawing/2014/main" id="{71BC2E85-B414-8BFE-572D-A51BAB578213}"/>
+            </a:ext>
+          </a:extLst>
+        </p:cNvPr>
         <p:cNvGrpSpPr/>
         <p:nvPr/>
       </p:nvGrpSpPr>
@@ -5538,7 +6662,7 @@
           <p:cNvPr id="2" name="Title 1">
             <a:extLst>
               <a:ext uri="{FF2B5EF4-FFF2-40B4-BE49-F238E27FC236}">
-                <a16:creationId xmlns:a16="http://schemas.microsoft.com/office/drawing/2014/main" id="{67841D5E-3956-1F1B-CB0C-100ECBCF637A}"/>
+                <a16:creationId xmlns:a16="http://schemas.microsoft.com/office/drawing/2014/main" id="{D93709A6-F230-C0B7-CD23-B6C5A04AB0DD}"/>
               </a:ext>
             </a:extLst>
           </p:cNvPr>
@@ -5563,10 +6687,10 @@
       </p:sp>
       <p:graphicFrame>
         <p:nvGraphicFramePr>
-          <p:cNvPr id="10" name="Table 9">
-            <a:extLst>
-              <a:ext uri="{FF2B5EF4-FFF2-40B4-BE49-F238E27FC236}">
-                <a16:creationId xmlns:a16="http://schemas.microsoft.com/office/drawing/2014/main" id="{D82D070E-CF95-1F9C-4A0E-419CC37B51AC}"/>
+          <p:cNvPr id="4" name="Table 3">
+            <a:extLst>
+              <a:ext uri="{FF2B5EF4-FFF2-40B4-BE49-F238E27FC236}">
+                <a16:creationId xmlns:a16="http://schemas.microsoft.com/office/drawing/2014/main" id="{BDE8B211-BD5C-E021-CBDC-5D85B782112B}"/>
               </a:ext>
             </a:extLst>
           </p:cNvPr>
@@ -5576,14 +6700,14 @@
           <p:nvPr>
             <p:extLst>
               <p:ext uri="{D42A27DB-BD31-4B8C-83A1-F6EECF244321}">
-                <p14:modId xmlns:p14="http://schemas.microsoft.com/office/powerpoint/2010/main" val="1475520597"/>
+                <p14:modId xmlns:p14="http://schemas.microsoft.com/office/powerpoint/2010/main" val="2539767233"/>
               </p:ext>
             </p:extLst>
           </p:nvPr>
         </p:nvGraphicFramePr>
         <p:xfrm>
-          <a:off x="12000" y="1527858"/>
-          <a:ext cx="12168000" cy="5217035"/>
+          <a:off x="24001" y="1499536"/>
+          <a:ext cx="12096880" cy="4998889"/>
         </p:xfrm>
         <a:graphic>
           <a:graphicData uri="http://schemas.openxmlformats.org/drawingml/2006/table">
@@ -5592,35 +6716,35 @@
                 <a:tableStyleId>{5C22544A-7EE6-4342-B048-85BDC9FD1C3A}</a:tableStyleId>
               </a:tblPr>
               <a:tblGrid>
-                <a:gridCol w="2880000">
+                <a:gridCol w="3356505">
                   <a:extLst>
                     <a:ext uri="{9D8B030D-6E8A-4147-A177-3AD203B41FA5}">
                       <a16:colId xmlns:a16="http://schemas.microsoft.com/office/drawing/2014/main" val="908099444"/>
                     </a:ext>
                   </a:extLst>
                 </a:gridCol>
-                <a:gridCol w="684000">
+                <a:gridCol w="1042797">
                   <a:extLst>
                     <a:ext uri="{9D8B030D-6E8A-4147-A177-3AD203B41FA5}">
                       <a16:colId xmlns:a16="http://schemas.microsoft.com/office/drawing/2014/main" val="304222866"/>
                     </a:ext>
                   </a:extLst>
                 </a:gridCol>
-                <a:gridCol w="3240000">
+                <a:gridCol w="1042797">
                   <a:extLst>
                     <a:ext uri="{9D8B030D-6E8A-4147-A177-3AD203B41FA5}">
                       <a16:colId xmlns:a16="http://schemas.microsoft.com/office/drawing/2014/main" val="1931972079"/>
                     </a:ext>
                   </a:extLst>
                 </a:gridCol>
-                <a:gridCol w="684000">
+                <a:gridCol w="1042797">
                   <a:extLst>
                     <a:ext uri="{9D8B030D-6E8A-4147-A177-3AD203B41FA5}">
                       <a16:colId xmlns:a16="http://schemas.microsoft.com/office/drawing/2014/main" val="3431500333"/>
                     </a:ext>
                   </a:extLst>
                 </a:gridCol>
-                <a:gridCol w="4680000">
+                <a:gridCol w="5611984">
                   <a:extLst>
                     <a:ext uri="{9D8B030D-6E8A-4147-A177-3AD203B41FA5}">
                       <a16:colId xmlns:a16="http://schemas.microsoft.com/office/drawing/2014/main" val="4084811004"/>
@@ -5634,70 +6758,115 @@
                     <a:bodyPr/>
                     <a:lstStyle/>
                     <a:p>
-                      <a:pPr algn="ctr"/>
-                      <a:r>
-                        <a:rPr lang="en-GB" dirty="0"/>
-                        <a:t>Cell 01</a:t>
-                      </a:r>
-                    </a:p>
-                  </a:txBody>
-                  <a:tcPr anchor="ctr"/>
-                </a:tc>
-                <a:tc>
-                  <a:txBody>
-                    <a:bodyPr/>
-                    <a:lstStyle/>
-                    <a:p>
-                      <a:pPr algn="ctr"/>
-                      <a:r>
-                        <a:rPr lang="en-GB" dirty="0"/>
-                        <a:t>z</a:t>
-                      </a:r>
-                    </a:p>
-                  </a:txBody>
-                  <a:tcPr anchor="ctr"/>
-                </a:tc>
-                <a:tc>
-                  <a:txBody>
-                    <a:bodyPr/>
-                    <a:lstStyle/>
-                    <a:p>
-                      <a:pPr algn="ctr"/>
-                      <a:r>
-                        <a:rPr lang="en-GB" dirty="0"/>
-                        <a:t>Cell 02</a:t>
-                      </a:r>
-                    </a:p>
-                  </a:txBody>
-                  <a:tcPr anchor="ctr"/>
-                </a:tc>
-                <a:tc>
-                  <a:txBody>
-                    <a:bodyPr/>
-                    <a:lstStyle/>
-                    <a:p>
-                      <a:pPr algn="ctr"/>
-                      <a:r>
-                        <a:rPr lang="en-GB" dirty="0"/>
-                        <a:t>z</a:t>
-                      </a:r>
-                    </a:p>
-                  </a:txBody>
-                  <a:tcPr anchor="ctr"/>
-                </a:tc>
-                <a:tc>
-                  <a:txBody>
-                    <a:bodyPr/>
-                    <a:lstStyle/>
-                    <a:p>
-                      <a:pPr algn="ctr"/>
-                      <a:r>
-                        <a:rPr lang="en-GB" dirty="0"/>
+                      <a:pPr marL="0" algn="ctr" defTabSz="914400" rtl="0" eaLnBrk="1" fontAlgn="b" latinLnBrk="0" hangingPunct="1">
+                        <a:buNone/>
+                      </a:pPr>
+                      <a:r>
+                        <a:rPr lang="en-GB" sz="1800" b="1" kern="1200" dirty="0">
+                          <a:solidFill>
+                            <a:schemeClr val="lt1"/>
+                          </a:solidFill>
+                          <a:latin typeface="+mn-lt"/>
+                          <a:ea typeface="+mn-ea"/>
+                          <a:cs typeface="+mn-cs"/>
+                        </a:rPr>
+                        <a:t>Property</a:t>
+                      </a:r>
+                    </a:p>
+                  </a:txBody>
+                  <a:tcPr marL="7620" marR="7620" marT="7620" marB="0" anchor="b"/>
+                </a:tc>
+                <a:tc>
+                  <a:txBody>
+                    <a:bodyPr/>
+                    <a:lstStyle/>
+                    <a:p>
+                      <a:pPr marL="0" algn="ctr" defTabSz="914400" rtl="0" eaLnBrk="1" fontAlgn="b" latinLnBrk="0" hangingPunct="1">
+                        <a:buNone/>
+                      </a:pPr>
+                      <a:r>
+                        <a:rPr lang="en-GB" sz="1800" b="1" kern="1200" dirty="0">
+                          <a:solidFill>
+                            <a:schemeClr val="lt1"/>
+                          </a:solidFill>
+                          <a:latin typeface="+mn-lt"/>
+                          <a:ea typeface="+mn-ea"/>
+                          <a:cs typeface="+mn-cs"/>
+                        </a:rPr>
+                        <a:t>C1</a:t>
+                      </a:r>
+                    </a:p>
+                  </a:txBody>
+                  <a:tcPr marL="7620" marR="7620" marT="7620" marB="0" anchor="b"/>
+                </a:tc>
+                <a:tc>
+                  <a:txBody>
+                    <a:bodyPr/>
+                    <a:lstStyle/>
+                    <a:p>
+                      <a:pPr marL="0" algn="ctr" defTabSz="914400" rtl="0" eaLnBrk="1" fontAlgn="b" latinLnBrk="0" hangingPunct="1">
+                        <a:buNone/>
+                      </a:pPr>
+                      <a:r>
+                        <a:rPr lang="en-GB" sz="1800" b="1" kern="1200" dirty="0">
+                          <a:solidFill>
+                            <a:schemeClr val="lt1"/>
+                          </a:solidFill>
+                          <a:latin typeface="+mn-lt"/>
+                          <a:ea typeface="+mn-ea"/>
+                          <a:cs typeface="+mn-cs"/>
+                        </a:rPr>
+                        <a:t>C2</a:t>
+                      </a:r>
+                    </a:p>
+                  </a:txBody>
+                  <a:tcPr marL="7620" marR="7620" marT="7620" marB="0" anchor="b"/>
+                </a:tc>
+                <a:tc>
+                  <a:txBody>
+                    <a:bodyPr/>
+                    <a:lstStyle/>
+                    <a:p>
+                      <a:pPr marL="0" algn="ctr" defTabSz="914400" rtl="0" eaLnBrk="1" fontAlgn="b" latinLnBrk="0" hangingPunct="1">
+                        <a:buNone/>
+                      </a:pPr>
+                      <a:r>
+                        <a:rPr lang="en-GB" sz="1800" b="1" kern="1200" dirty="0">
+                          <a:solidFill>
+                            <a:schemeClr val="lt1"/>
+                          </a:solidFill>
+                          <a:latin typeface="+mn-lt"/>
+                          <a:ea typeface="+mn-ea"/>
+                          <a:cs typeface="+mn-cs"/>
+                        </a:rPr>
+                        <a:t>C3</a:t>
+                      </a:r>
+                    </a:p>
+                  </a:txBody>
+                  <a:tcPr marL="7620" marR="7620" marT="7620" marB="0" anchor="b"/>
+                </a:tc>
+                <a:tc>
+                  <a:txBody>
+                    <a:bodyPr/>
+                    <a:lstStyle/>
+                    <a:p>
+                      <a:pPr marL="0" algn="ctr" defTabSz="914400" rtl="0" eaLnBrk="1" fontAlgn="b" latinLnBrk="0" hangingPunct="1">
+                        <a:buNone/>
+                      </a:pPr>
+                      <a:r>
+                        <a:rPr lang="en-GB" sz="1800" b="1" kern="1200" dirty="0">
+                          <a:solidFill>
+                            <a:schemeClr val="lt1"/>
+                          </a:solidFill>
+                          <a:latin typeface="+mn-lt"/>
+                          <a:ea typeface="+mn-ea"/>
+                          <a:cs typeface="+mn-cs"/>
+                        </a:rPr>
                         <a:t>Plain English</a:t>
                       </a:r>
                     </a:p>
                   </a:txBody>
-                  <a:tcPr anchor="ctr">
+                  <a:tcPr marL="7620" marR="7620" marT="7620" marB="0" anchor="b">
                     <a:solidFill>
                       <a:schemeClr val="bg2">
                         <a:lumMod val="25000"/>
@@ -5717,64 +6886,123 @@
                     <a:bodyPr/>
                     <a:lstStyle/>
                     <a:p>
-                      <a:pPr algn="ctr"/>
-                      <a:r>
-                        <a:rPr lang="en-GB" sz="1500" b="0" dirty="0"/>
+                      <a:pPr marL="0" algn="ctr" defTabSz="914400" rtl="0" eaLnBrk="1" fontAlgn="b" latinLnBrk="0" hangingPunct="1">
+                        <a:buNone/>
+                      </a:pPr>
+                      <a:r>
+                        <a:rPr lang="en-GB" sz="1800" b="0" kern="1200" dirty="0" err="1">
+                          <a:solidFill>
+                            <a:sysClr val="windowText" lastClr="000000"/>
+                          </a:solidFill>
+                          <a:latin typeface="+mn-lt"/>
+                          <a:ea typeface="+mn-ea"/>
+                          <a:cs typeface="+mn-cs"/>
+                        </a:rPr>
                         <a:t>nucleus_volume</a:t>
                       </a:r>
-                    </a:p>
-                  </a:txBody>
-                  <a:tcPr anchor="ctr"/>
-                </a:tc>
-                <a:tc>
-                  <a:txBody>
-                    <a:bodyPr/>
-                    <a:lstStyle/>
-                    <a:p>
-                      <a:pPr algn="ctr"/>
-                      <a:r>
-                        <a:rPr lang="en-GB" sz="1500" b="0" dirty="0"/>
+                      <a:endParaRPr lang="en-GB" sz="1800" b="0" kern="1200" dirty="0">
+                        <a:solidFill>
+                          <a:sysClr val="windowText" lastClr="000000"/>
+                        </a:solidFill>
+                        <a:latin typeface="+mn-lt"/>
+                        <a:ea typeface="+mn-ea"/>
+                        <a:cs typeface="+mn-cs"/>
+                      </a:endParaRPr>
+                    </a:p>
+                  </a:txBody>
+                  <a:tcPr marL="7620" marR="7620" marT="7620" marB="0" anchor="b"/>
+                </a:tc>
+                <a:tc>
+                  <a:txBody>
+                    <a:bodyPr/>
+                    <a:lstStyle/>
+                    <a:p>
+                      <a:pPr marL="0" algn="ctr" defTabSz="914400" rtl="0" eaLnBrk="1" fontAlgn="b" latinLnBrk="0" hangingPunct="1">
+                        <a:buNone/>
+                      </a:pPr>
+                      <a:r>
+                        <a:rPr lang="en-GB" sz="1800" b="0" kern="1200" dirty="0">
+                          <a:solidFill>
+                            <a:sysClr val="windowText" lastClr="000000"/>
+                          </a:solidFill>
+                          <a:latin typeface="+mn-lt"/>
+                          <a:ea typeface="+mn-ea"/>
+                          <a:cs typeface="+mn-cs"/>
+                        </a:rPr>
                         <a:t>2.53</a:t>
                       </a:r>
                     </a:p>
                   </a:txBody>
-                  <a:tcPr anchor="ctr"/>
-                </a:tc>
-                <a:tc>
-                  <a:txBody>
-                    <a:bodyPr/>
-                    <a:lstStyle/>
-                    <a:p>
-                      <a:pPr algn="ctr"/>
-                      <a:endParaRPr lang="en-GB" sz="1500" b="0" dirty="0"/>
-                    </a:p>
-                  </a:txBody>
-                  <a:tcPr anchor="ctr"/>
-                </a:tc>
-                <a:tc>
-                  <a:txBody>
-                    <a:bodyPr/>
-                    <a:lstStyle/>
-                    <a:p>
-                      <a:pPr algn="ctr"/>
-                      <a:endParaRPr lang="en-GB" sz="1500" b="0" dirty="0"/>
-                    </a:p>
-                  </a:txBody>
-                  <a:tcPr anchor="ctr"/>
-                </a:tc>
-                <a:tc>
-                  <a:txBody>
-                    <a:bodyPr/>
-                    <a:lstStyle/>
-                    <a:p>
-                      <a:pPr algn="ctr"/>
-                      <a:r>
-                        <a:rPr lang="en-GB" sz="1500" b="0" dirty="0"/>
+                  <a:tcPr marL="7620" marR="7620" marT="7620" marB="0" anchor="b"/>
+                </a:tc>
+                <a:tc>
+                  <a:txBody>
+                    <a:bodyPr/>
+                    <a:lstStyle/>
+                    <a:p>
+                      <a:pPr marL="0" algn="ctr" defTabSz="914400" rtl="0" eaLnBrk="1" fontAlgn="b" latinLnBrk="0" hangingPunct="1">
+                        <a:buNone/>
+                      </a:pPr>
+                      <a:r>
+                        <a:rPr lang="en-GB" sz="1800" b="0" kern="1200">
+                          <a:solidFill>
+                            <a:sysClr val="windowText" lastClr="000000"/>
+                          </a:solidFill>
+                          <a:latin typeface="+mn-lt"/>
+                          <a:ea typeface="+mn-ea"/>
+                          <a:cs typeface="+mn-cs"/>
+                        </a:rPr>
+                        <a:t>-</a:t>
+                      </a:r>
+                    </a:p>
+                  </a:txBody>
+                  <a:tcPr marL="7620" marR="7620" marT="7620" marB="0" anchor="b"/>
+                </a:tc>
+                <a:tc>
+                  <a:txBody>
+                    <a:bodyPr/>
+                    <a:lstStyle/>
+                    <a:p>
+                      <a:pPr marL="0" algn="ctr" defTabSz="914400" rtl="0" eaLnBrk="1" fontAlgn="b" latinLnBrk="0" hangingPunct="1">
+                        <a:buNone/>
+                      </a:pPr>
+                      <a:r>
+                        <a:rPr lang="en-GB" sz="1800" b="0" kern="1200" dirty="0">
+                          <a:solidFill>
+                            <a:sysClr val="windowText" lastClr="000000"/>
+                          </a:solidFill>
+                          <a:latin typeface="+mn-lt"/>
+                          <a:ea typeface="+mn-ea"/>
+                          <a:cs typeface="+mn-cs"/>
+                        </a:rPr>
+                        <a:t>-</a:t>
+                      </a:r>
+                    </a:p>
+                  </a:txBody>
+                  <a:tcPr marL="7620" marR="7620" marT="7620" marB="0" anchor="b"/>
+                </a:tc>
+                <a:tc>
+                  <a:txBody>
+                    <a:bodyPr/>
+                    <a:lstStyle/>
+                    <a:p>
+                      <a:pPr marL="0" algn="ctr" defTabSz="914400" rtl="0" eaLnBrk="1" fontAlgn="b" latinLnBrk="0" hangingPunct="1">
+                        <a:buNone/>
+                      </a:pPr>
+                      <a:r>
+                        <a:rPr lang="en-GB" sz="1800" b="0" kern="1200">
+                          <a:solidFill>
+                            <a:sysClr val="windowText" lastClr="000000"/>
+                          </a:solidFill>
+                          <a:latin typeface="+mn-lt"/>
+                          <a:ea typeface="+mn-ea"/>
+                          <a:cs typeface="+mn-cs"/>
+                        </a:rPr>
                         <a:t>Volume of the nucleus</a:t>
                       </a:r>
                     </a:p>
                   </a:txBody>
-                  <a:tcPr anchor="ctr">
+                  <a:tcPr marL="7620" marR="7620" marT="7620" marB="0" anchor="b">
                     <a:solidFill>
                       <a:schemeClr val="bg2">
                         <a:lumMod val="90000"/>
@@ -5794,72 +7022,123 @@
                     <a:bodyPr/>
                     <a:lstStyle/>
                     <a:p>
-                      <a:pPr algn="ctr"/>
-                      <a:r>
-                        <a:rPr lang="en-GB" sz="1500" b="1" dirty="0" err="1"/>
+                      <a:pPr marL="0" algn="ctr" defTabSz="914400" rtl="0" eaLnBrk="1" fontAlgn="b" latinLnBrk="0" hangingPunct="1">
+                        <a:buNone/>
+                      </a:pPr>
+                      <a:r>
+                        <a:rPr lang="en-GB" sz="1800" b="1" kern="1200" dirty="0" err="1">
+                          <a:solidFill>
+                            <a:sysClr val="windowText" lastClr="000000"/>
+                          </a:solidFill>
+                          <a:latin typeface="+mn-lt"/>
+                          <a:ea typeface="+mn-ea"/>
+                          <a:cs typeface="+mn-cs"/>
+                        </a:rPr>
                         <a:t>mitocloud_anisotropy</a:t>
                       </a:r>
-                      <a:endParaRPr lang="en-GB" sz="1500" b="1" dirty="0"/>
-                    </a:p>
-                  </a:txBody>
-                  <a:tcPr anchor="ctr"/>
-                </a:tc>
-                <a:tc>
-                  <a:txBody>
-                    <a:bodyPr/>
-                    <a:lstStyle/>
-                    <a:p>
-                      <a:pPr algn="ctr"/>
-                      <a:r>
-                        <a:rPr lang="en-GB" sz="1500" b="1" dirty="0"/>
-                        <a:t>10.20</a:t>
-                      </a:r>
-                    </a:p>
-                  </a:txBody>
-                  <a:tcPr anchor="ctr"/>
-                </a:tc>
-                <a:tc>
-                  <a:txBody>
-                    <a:bodyPr/>
-                    <a:lstStyle/>
-                    <a:p>
-                      <a:pPr algn="ctr"/>
-                      <a:r>
-                        <a:rPr lang="en-GB" sz="1500" b="1" dirty="0" err="1"/>
-                        <a:t>mitocloud_anisotropy</a:t>
-                      </a:r>
-                      <a:endParaRPr lang="en-GB" sz="1500" b="1" dirty="0"/>
-                    </a:p>
-                  </a:txBody>
-                  <a:tcPr anchor="ctr"/>
-                </a:tc>
-                <a:tc>
-                  <a:txBody>
-                    <a:bodyPr/>
-                    <a:lstStyle/>
-                    <a:p>
-                      <a:pPr algn="ctr"/>
-                      <a:r>
-                        <a:rPr lang="en-GB" sz="1500" b="1" dirty="0"/>
-                        <a:t>4.50</a:t>
-                      </a:r>
-                    </a:p>
-                  </a:txBody>
-                  <a:tcPr anchor="ctr"/>
-                </a:tc>
-                <a:tc>
-                  <a:txBody>
-                    <a:bodyPr/>
-                    <a:lstStyle/>
-                    <a:p>
-                      <a:pPr algn="ctr"/>
-                      <a:r>
-                        <a:rPr lang="en-GB" sz="1500" b="0" dirty="0"/>
+                      <a:endParaRPr lang="en-GB" sz="1800" b="1" kern="1200" dirty="0">
+                        <a:solidFill>
+                          <a:sysClr val="windowText" lastClr="000000"/>
+                        </a:solidFill>
+                        <a:latin typeface="+mn-lt"/>
+                        <a:ea typeface="+mn-ea"/>
+                        <a:cs typeface="+mn-cs"/>
+                      </a:endParaRPr>
+                    </a:p>
+                  </a:txBody>
+                  <a:tcPr marL="7620" marR="7620" marT="7620" marB="0" anchor="b"/>
+                </a:tc>
+                <a:tc>
+                  <a:txBody>
+                    <a:bodyPr/>
+                    <a:lstStyle/>
+                    <a:p>
+                      <a:pPr marL="0" algn="ctr" defTabSz="914400" rtl="0" eaLnBrk="1" fontAlgn="b" latinLnBrk="0" hangingPunct="1">
+                        <a:buNone/>
+                      </a:pPr>
+                      <a:r>
+                        <a:rPr lang="en-GB" sz="1800" b="1" kern="1200" dirty="0">
+                          <a:solidFill>
+                            <a:sysClr val="windowText" lastClr="000000"/>
+                          </a:solidFill>
+                          <a:latin typeface="+mn-lt"/>
+                          <a:ea typeface="+mn-ea"/>
+                          <a:cs typeface="+mn-cs"/>
+                        </a:rPr>
+                        <a:t>10.2</a:t>
+                      </a:r>
+                    </a:p>
+                  </a:txBody>
+                  <a:tcPr marL="7620" marR="7620" marT="7620" marB="0" anchor="b"/>
+                </a:tc>
+                <a:tc>
+                  <a:txBody>
+                    <a:bodyPr/>
+                    <a:lstStyle/>
+                    <a:p>
+                      <a:pPr marL="0" algn="ctr" defTabSz="914400" rtl="0" eaLnBrk="1" fontAlgn="b" latinLnBrk="0" hangingPunct="1">
+                        <a:buNone/>
+                      </a:pPr>
+                      <a:r>
+                        <a:rPr lang="en-GB" sz="1800" b="1" kern="1200" dirty="0">
+                          <a:solidFill>
+                            <a:sysClr val="windowText" lastClr="000000"/>
+                          </a:solidFill>
+                          <a:latin typeface="+mn-lt"/>
+                          <a:ea typeface="+mn-ea"/>
+                          <a:cs typeface="+mn-cs"/>
+                        </a:rPr>
+                        <a:t>4.5</a:t>
+                      </a:r>
+                    </a:p>
+                  </a:txBody>
+                  <a:tcPr marL="7620" marR="7620" marT="7620" marB="0" anchor="b"/>
+                </a:tc>
+                <a:tc>
+                  <a:txBody>
+                    <a:bodyPr/>
+                    <a:lstStyle/>
+                    <a:p>
+                      <a:pPr marL="0" algn="ctr" defTabSz="914400" rtl="0" eaLnBrk="1" fontAlgn="b" latinLnBrk="0" hangingPunct="1">
+                        <a:buNone/>
+                      </a:pPr>
+                      <a:r>
+                        <a:rPr lang="en-GB" sz="1800" b="1" kern="1200" dirty="0">
+                          <a:solidFill>
+                            <a:sysClr val="windowText" lastClr="000000"/>
+                          </a:solidFill>
+                          <a:latin typeface="+mn-lt"/>
+                          <a:ea typeface="+mn-ea"/>
+                          <a:cs typeface="+mn-cs"/>
+                        </a:rPr>
+                        <a:t>3.82</a:t>
+                      </a:r>
+                    </a:p>
+                  </a:txBody>
+                  <a:tcPr marL="7620" marR="7620" marT="7620" marB="0" anchor="b"/>
+                </a:tc>
+                <a:tc>
+                  <a:txBody>
+                    <a:bodyPr/>
+                    <a:lstStyle/>
+                    <a:p>
+                      <a:pPr marL="0" algn="ctr" defTabSz="914400" rtl="0" eaLnBrk="1" fontAlgn="b" latinLnBrk="0" hangingPunct="1">
+                        <a:buNone/>
+                      </a:pPr>
+                      <a:r>
+                        <a:rPr lang="en-GB" sz="1800" b="1" kern="1200" dirty="0">
+                          <a:solidFill>
+                            <a:sysClr val="windowText" lastClr="000000"/>
+                          </a:solidFill>
+                          <a:latin typeface="+mn-lt"/>
+                          <a:ea typeface="+mn-ea"/>
+                          <a:cs typeface="+mn-cs"/>
+                        </a:rPr>
                         <a:t>How elongated (like aspect ratio)</a:t>
                       </a:r>
                     </a:p>
                   </a:txBody>
-                  <a:tcPr anchor="ctr">
+                  <a:tcPr marL="7620" marR="7620" marT="7620" marB="0" anchor="b">
                     <a:solidFill>
                       <a:schemeClr val="bg2"/>
                     </a:solidFill>
@@ -5877,70 +7156,115 @@
                     <a:bodyPr/>
                     <a:lstStyle/>
                     <a:p>
-                      <a:pPr algn="ctr"/>
-                      <a:r>
-                        <a:rPr lang="en-GB" sz="1500" b="0" dirty="0"/>
+                      <a:pPr marL="0" algn="ctr" defTabSz="914400" rtl="0" eaLnBrk="1" fontAlgn="b" latinLnBrk="0" hangingPunct="1">
+                        <a:buNone/>
+                      </a:pPr>
+                      <a:r>
+                        <a:rPr lang="en-GB" sz="1800" b="0" kern="1200" dirty="0">
+                          <a:solidFill>
+                            <a:sysClr val="windowText" lastClr="000000"/>
+                          </a:solidFill>
+                          <a:latin typeface="+mn-lt"/>
+                          <a:ea typeface="+mn-ea"/>
+                          <a:cs typeface="+mn-cs"/>
+                        </a:rPr>
                         <a:t>nucleus_mitocloud_L1</a:t>
                       </a:r>
                     </a:p>
                   </a:txBody>
-                  <a:tcPr anchor="ctr"/>
-                </a:tc>
-                <a:tc>
-                  <a:txBody>
-                    <a:bodyPr/>
-                    <a:lstStyle/>
-                    <a:p>
-                      <a:pPr algn="ctr"/>
-                      <a:r>
-                        <a:rPr lang="en-GB" sz="1500" b="0" dirty="0"/>
+                  <a:tcPr marL="7620" marR="7620" marT="7620" marB="0" anchor="b"/>
+                </a:tc>
+                <a:tc>
+                  <a:txBody>
+                    <a:bodyPr/>
+                    <a:lstStyle/>
+                    <a:p>
+                      <a:pPr marL="0" algn="ctr" defTabSz="914400" rtl="0" eaLnBrk="1" fontAlgn="b" latinLnBrk="0" hangingPunct="1">
+                        <a:buNone/>
+                      </a:pPr>
+                      <a:r>
+                        <a:rPr lang="en-GB" sz="1800" b="0" kern="1200">
+                          <a:solidFill>
+                            <a:sysClr val="windowText" lastClr="000000"/>
+                          </a:solidFill>
+                          <a:latin typeface="+mn-lt"/>
+                          <a:ea typeface="+mn-ea"/>
+                          <a:cs typeface="+mn-cs"/>
+                        </a:rPr>
                         <a:t>7.41</a:t>
                       </a:r>
                     </a:p>
                   </a:txBody>
-                  <a:tcPr anchor="ctr"/>
-                </a:tc>
-                <a:tc>
-                  <a:txBody>
-                    <a:bodyPr/>
-                    <a:lstStyle/>
-                    <a:p>
-                      <a:pPr algn="ctr"/>
-                      <a:r>
-                        <a:rPr lang="en-GB" sz="1500" b="0" dirty="0"/>
-                        <a:t>nucleus_mitocloud_L1</a:t>
-                      </a:r>
-                    </a:p>
-                  </a:txBody>
-                  <a:tcPr anchor="ctr"/>
-                </a:tc>
-                <a:tc>
-                  <a:txBody>
-                    <a:bodyPr/>
-                    <a:lstStyle/>
-                    <a:p>
-                      <a:pPr algn="ctr"/>
-                      <a:r>
-                        <a:rPr lang="en-GB" sz="1500" b="0" dirty="0"/>
+                  <a:tcPr marL="7620" marR="7620" marT="7620" marB="0" anchor="b"/>
+                </a:tc>
+                <a:tc>
+                  <a:txBody>
+                    <a:bodyPr/>
+                    <a:lstStyle/>
+                    <a:p>
+                      <a:pPr marL="0" algn="ctr" defTabSz="914400" rtl="0" eaLnBrk="1" fontAlgn="b" latinLnBrk="0" hangingPunct="1">
+                        <a:buNone/>
+                      </a:pPr>
+                      <a:r>
+                        <a:rPr lang="en-GB" sz="1800" b="0" kern="1200" dirty="0">
+                          <a:solidFill>
+                            <a:sysClr val="windowText" lastClr="000000"/>
+                          </a:solidFill>
+                          <a:latin typeface="+mn-lt"/>
+                          <a:ea typeface="+mn-ea"/>
+                          <a:cs typeface="+mn-cs"/>
+                        </a:rPr>
                         <a:t>5.19</a:t>
                       </a:r>
                     </a:p>
                   </a:txBody>
-                  <a:tcPr anchor="ctr"/>
-                </a:tc>
-                <a:tc>
-                  <a:txBody>
-                    <a:bodyPr/>
-                    <a:lstStyle/>
-                    <a:p>
-                      <a:pPr algn="ctr"/>
-                      <a:r>
-                        <a:rPr lang="en-GB" sz="1500" b="0" dirty="0"/>
+                  <a:tcPr marL="7620" marR="7620" marT="7620" marB="0" anchor="b"/>
+                </a:tc>
+                <a:tc>
+                  <a:txBody>
+                    <a:bodyPr/>
+                    <a:lstStyle/>
+                    <a:p>
+                      <a:pPr marL="0" algn="ctr" defTabSz="914400" rtl="0" eaLnBrk="1" fontAlgn="b" latinLnBrk="0" hangingPunct="1">
+                        <a:buNone/>
+                      </a:pPr>
+                      <a:r>
+                        <a:rPr lang="en-GB" sz="1800" b="0" kern="1200" dirty="0">
+                          <a:solidFill>
+                            <a:sysClr val="windowText" lastClr="000000"/>
+                          </a:solidFill>
+                          <a:latin typeface="+mn-lt"/>
+                          <a:ea typeface="+mn-ea"/>
+                          <a:cs typeface="+mn-cs"/>
+                        </a:rPr>
+                        <a:t>3.30</a:t>
+                      </a:r>
+                    </a:p>
+                  </a:txBody>
+                  <a:tcPr marL="7620" marR="7620" marT="7620" marB="0" anchor="b"/>
+                </a:tc>
+                <a:tc>
+                  <a:txBody>
+                    <a:bodyPr/>
+                    <a:lstStyle/>
+                    <a:p>
+                      <a:pPr marL="0" algn="ctr" defTabSz="914400" rtl="0" eaLnBrk="1" fontAlgn="b" latinLnBrk="0" hangingPunct="1">
+                        <a:buNone/>
+                      </a:pPr>
+                      <a:r>
+                        <a:rPr lang="en-GB" sz="1800" b="0" kern="1200" dirty="0">
+                          <a:solidFill>
+                            <a:sysClr val="windowText" lastClr="000000"/>
+                          </a:solidFill>
+                          <a:latin typeface="+mn-lt"/>
+                          <a:ea typeface="+mn-ea"/>
+                          <a:cs typeface="+mn-cs"/>
+                        </a:rPr>
                         <a:t>Spread along long axis</a:t>
                       </a:r>
                     </a:p>
                   </a:txBody>
-                  <a:tcPr anchor="ctr">
+                  <a:tcPr marL="7620" marR="7620" marT="7620" marB="0" anchor="b">
                     <a:solidFill>
                       <a:schemeClr val="bg2">
                         <a:lumMod val="90000"/>
@@ -5960,64 +7284,115 @@
                     <a:bodyPr/>
                     <a:lstStyle/>
                     <a:p>
-                      <a:pPr algn="ctr"/>
-                      <a:endParaRPr lang="en-GB" sz="1500" b="0" dirty="0"/>
-                    </a:p>
-                  </a:txBody>
-                  <a:tcPr anchor="ctr"/>
-                </a:tc>
-                <a:tc>
-                  <a:txBody>
-                    <a:bodyPr/>
-                    <a:lstStyle/>
-                    <a:p>
-                      <a:pPr algn="ctr"/>
-                      <a:endParaRPr lang="en-GB" sz="1500" b="0" dirty="0"/>
-                    </a:p>
-                  </a:txBody>
-                  <a:tcPr anchor="ctr"/>
-                </a:tc>
-                <a:tc>
-                  <a:txBody>
-                    <a:bodyPr/>
-                    <a:lstStyle/>
-                    <a:p>
-                      <a:pPr algn="ctr"/>
-                      <a:r>
-                        <a:rPr lang="en-GB" sz="1500" b="0" dirty="0"/>
+                      <a:pPr marL="0" algn="ctr" defTabSz="914400" rtl="0" eaLnBrk="1" fontAlgn="b" latinLnBrk="0" hangingPunct="1">
+                        <a:buNone/>
+                      </a:pPr>
+                      <a:r>
+                        <a:rPr lang="en-GB" sz="1800" b="0" kern="1200" dirty="0">
+                          <a:solidFill>
+                            <a:sysClr val="windowText" lastClr="000000"/>
+                          </a:solidFill>
+                          <a:latin typeface="+mn-lt"/>
+                          <a:ea typeface="+mn-ea"/>
+                          <a:cs typeface="+mn-cs"/>
+                        </a:rPr>
                         <a:t>nucleus_mitocloud_L2</a:t>
                       </a:r>
                     </a:p>
                   </a:txBody>
-                  <a:tcPr anchor="ctr"/>
-                </a:tc>
-                <a:tc>
-                  <a:txBody>
-                    <a:bodyPr/>
-                    <a:lstStyle/>
-                    <a:p>
-                      <a:pPr algn="ctr"/>
-                      <a:r>
-                        <a:rPr lang="en-GB" sz="1500" b="0" dirty="0"/>
+                  <a:tcPr marL="7620" marR="7620" marT="7620" marB="0" anchor="b"/>
+                </a:tc>
+                <a:tc>
+                  <a:txBody>
+                    <a:bodyPr/>
+                    <a:lstStyle/>
+                    <a:p>
+                      <a:pPr marL="0" algn="ctr" defTabSz="914400" rtl="0" eaLnBrk="1" fontAlgn="b" latinLnBrk="0" hangingPunct="1">
+                        <a:buNone/>
+                      </a:pPr>
+                      <a:r>
+                        <a:rPr lang="en-GB" sz="1800" b="0" kern="1200">
+                          <a:solidFill>
+                            <a:sysClr val="windowText" lastClr="000000"/>
+                          </a:solidFill>
+                          <a:latin typeface="+mn-lt"/>
+                          <a:ea typeface="+mn-ea"/>
+                          <a:cs typeface="+mn-cs"/>
+                        </a:rPr>
+                        <a:t>-</a:t>
+                      </a:r>
+                    </a:p>
+                  </a:txBody>
+                  <a:tcPr marL="7620" marR="7620" marT="7620" marB="0" anchor="b"/>
+                </a:tc>
+                <a:tc>
+                  <a:txBody>
+                    <a:bodyPr/>
+                    <a:lstStyle/>
+                    <a:p>
+                      <a:pPr marL="0" algn="ctr" defTabSz="914400" rtl="0" eaLnBrk="1" fontAlgn="b" latinLnBrk="0" hangingPunct="1">
+                        <a:buNone/>
+                      </a:pPr>
+                      <a:r>
+                        <a:rPr lang="en-GB" sz="1800" b="0" kern="1200" dirty="0">
+                          <a:solidFill>
+                            <a:sysClr val="windowText" lastClr="000000"/>
+                          </a:solidFill>
+                          <a:latin typeface="+mn-lt"/>
+                          <a:ea typeface="+mn-ea"/>
+                          <a:cs typeface="+mn-cs"/>
+                        </a:rPr>
                         <a:t>2.32</a:t>
                       </a:r>
                     </a:p>
                   </a:txBody>
-                  <a:tcPr anchor="ctr"/>
-                </a:tc>
-                <a:tc>
-                  <a:txBody>
-                    <a:bodyPr/>
-                    <a:lstStyle/>
-                    <a:p>
-                      <a:pPr algn="ctr"/>
-                      <a:r>
-                        <a:rPr lang="en-GB" sz="1500" b="0" dirty="0"/>
+                  <a:tcPr marL="7620" marR="7620" marT="7620" marB="0" anchor="b"/>
+                </a:tc>
+                <a:tc>
+                  <a:txBody>
+                    <a:bodyPr/>
+                    <a:lstStyle/>
+                    <a:p>
+                      <a:pPr marL="0" algn="ctr" defTabSz="914400" rtl="0" eaLnBrk="1" fontAlgn="b" latinLnBrk="0" hangingPunct="1">
+                        <a:buNone/>
+                      </a:pPr>
+                      <a:r>
+                        <a:rPr lang="en-GB" sz="1800" b="0" kern="1200">
+                          <a:solidFill>
+                            <a:sysClr val="windowText" lastClr="000000"/>
+                          </a:solidFill>
+                          <a:latin typeface="+mn-lt"/>
+                          <a:ea typeface="+mn-ea"/>
+                          <a:cs typeface="+mn-cs"/>
+                        </a:rPr>
+                        <a:t>-</a:t>
+                      </a:r>
+                    </a:p>
+                  </a:txBody>
+                  <a:tcPr marL="7620" marR="7620" marT="7620" marB="0" anchor="b"/>
+                </a:tc>
+                <a:tc>
+                  <a:txBody>
+                    <a:bodyPr/>
+                    <a:lstStyle/>
+                    <a:p>
+                      <a:pPr marL="0" algn="ctr" defTabSz="914400" rtl="0" eaLnBrk="1" fontAlgn="b" latinLnBrk="0" hangingPunct="1">
+                        <a:buNone/>
+                      </a:pPr>
+                      <a:r>
+                        <a:rPr lang="en-GB" sz="1800" b="0" kern="1200">
+                          <a:solidFill>
+                            <a:sysClr val="windowText" lastClr="000000"/>
+                          </a:solidFill>
+                          <a:latin typeface="+mn-lt"/>
+                          <a:ea typeface="+mn-ea"/>
+                          <a:cs typeface="+mn-cs"/>
+                        </a:rPr>
                         <a:t>Spread along mid axis</a:t>
                       </a:r>
                     </a:p>
                   </a:txBody>
-                  <a:tcPr anchor="ctr">
+                  <a:tcPr marL="7620" marR="7620" marT="7620" marB="0" anchor="b">
                     <a:solidFill>
                       <a:schemeClr val="bg2"/>
                     </a:solidFill>
@@ -6035,81 +7410,123 @@
                     <a:bodyPr/>
                     <a:lstStyle/>
                     <a:p>
-                      <a:pPr algn="ctr"/>
-                      <a:endParaRPr lang="en-GB" sz="1500" b="0" dirty="0"/>
-                    </a:p>
-                  </a:txBody>
-                  <a:tcPr anchor="ctr"/>
-                </a:tc>
-                <a:tc>
-                  <a:txBody>
-                    <a:bodyPr/>
-                    <a:lstStyle/>
-                    <a:p>
-                      <a:pPr algn="ctr"/>
-                      <a:endParaRPr lang="en-GB" sz="1500" b="0" dirty="0"/>
-                    </a:p>
-                  </a:txBody>
-                  <a:tcPr anchor="ctr"/>
-                </a:tc>
-                <a:tc>
-                  <a:txBody>
-                    <a:bodyPr/>
-                    <a:lstStyle/>
-                    <a:p>
-                      <a:pPr algn="ctr"/>
-                      <a:r>
-                        <a:rPr lang="en-GB" sz="1500" b="0" dirty="0" err="1"/>
+                      <a:pPr marL="0" algn="ctr" defTabSz="914400" rtl="0" eaLnBrk="1" fontAlgn="b" latinLnBrk="0" hangingPunct="1">
+                        <a:buNone/>
+                      </a:pPr>
+                      <a:r>
+                        <a:rPr lang="en-GB" sz="1800" b="0" kern="1200" dirty="0" err="1">
+                          <a:solidFill>
+                            <a:sysClr val="windowText" lastClr="000000"/>
+                          </a:solidFill>
+                          <a:latin typeface="+mn-lt"/>
+                          <a:ea typeface="+mn-ea"/>
+                          <a:cs typeface="+mn-cs"/>
+                        </a:rPr>
                         <a:t>nucleus_distance_of_centroids</a:t>
                       </a:r>
-                      <a:endParaRPr lang="en-GB" sz="1500" b="0" dirty="0"/>
-                    </a:p>
-                  </a:txBody>
-                  <a:tcPr anchor="ctr"/>
-                </a:tc>
-                <a:tc>
-                  <a:txBody>
-                    <a:bodyPr/>
-                    <a:lstStyle/>
-                    <a:p>
-                      <a:pPr algn="ctr"/>
-                      <a:r>
-                        <a:rPr lang="en-GB" sz="1500" b="0" dirty="0"/>
+                      <a:endParaRPr lang="en-GB" sz="1800" b="0" kern="1200" dirty="0">
+                        <a:solidFill>
+                          <a:sysClr val="windowText" lastClr="000000"/>
+                        </a:solidFill>
+                        <a:latin typeface="+mn-lt"/>
+                        <a:ea typeface="+mn-ea"/>
+                        <a:cs typeface="+mn-cs"/>
+                      </a:endParaRPr>
+                    </a:p>
+                  </a:txBody>
+                  <a:tcPr marL="7620" marR="7620" marT="7620" marB="0" anchor="b"/>
+                </a:tc>
+                <a:tc>
+                  <a:txBody>
+                    <a:bodyPr/>
+                    <a:lstStyle/>
+                    <a:p>
+                      <a:pPr marL="0" algn="ctr" defTabSz="914400" rtl="0" eaLnBrk="1" fontAlgn="b" latinLnBrk="0" hangingPunct="1">
+                        <a:buNone/>
+                      </a:pPr>
+                      <a:r>
+                        <a:rPr lang="en-GB" sz="1800" b="0" kern="1200">
+                          <a:solidFill>
+                            <a:sysClr val="windowText" lastClr="000000"/>
+                          </a:solidFill>
+                          <a:latin typeface="+mn-lt"/>
+                          <a:ea typeface="+mn-ea"/>
+                          <a:cs typeface="+mn-cs"/>
+                        </a:rPr>
+                        <a:t>-</a:t>
+                      </a:r>
+                    </a:p>
+                  </a:txBody>
+                  <a:tcPr marL="7620" marR="7620" marT="7620" marB="0" anchor="b"/>
+                </a:tc>
+                <a:tc>
+                  <a:txBody>
+                    <a:bodyPr/>
+                    <a:lstStyle/>
+                    <a:p>
+                      <a:pPr marL="0" algn="ctr" defTabSz="914400" rtl="0" eaLnBrk="1" fontAlgn="b" latinLnBrk="0" hangingPunct="1">
+                        <a:buNone/>
+                      </a:pPr>
+                      <a:r>
+                        <a:rPr lang="en-GB" sz="1800" b="0" kern="1200">
+                          <a:solidFill>
+                            <a:sysClr val="windowText" lastClr="000000"/>
+                          </a:solidFill>
+                          <a:latin typeface="+mn-lt"/>
+                          <a:ea typeface="+mn-ea"/>
+                          <a:cs typeface="+mn-cs"/>
+                        </a:rPr>
                         <a:t>2.29</a:t>
                       </a:r>
                     </a:p>
                   </a:txBody>
-                  <a:tcPr anchor="ctr"/>
-                </a:tc>
-                <a:tc>
-                  <a:txBody>
-                    <a:bodyPr/>
-                    <a:lstStyle/>
-                    <a:p>
-                      <a:pPr algn="ctr"/>
-                      <a:r>
-                        <a:rPr lang="en-GB" sz="1500" b="0" dirty="0"/>
-                        <a:t>Distance between </a:t>
-                      </a:r>
-                      <a:r>
-                        <a:rPr lang="en-GB" sz="1500" b="0" dirty="0" err="1"/>
-                        <a:t>nuc</a:t>
-                      </a:r>
-                      <a:r>
-                        <a:rPr lang="en-GB" sz="1500" b="0" dirty="0"/>
-                        <a:t> centroid and </a:t>
-                      </a:r>
-                      <a:r>
-                        <a:rPr lang="en-GB" sz="1500" b="0" dirty="0" err="1"/>
-                        <a:t>mitocloud</a:t>
-                      </a:r>
-                      <a:r>
-                        <a:rPr lang="en-GB" sz="1500" b="0" dirty="0"/>
-                        <a:t> centroid</a:t>
-                      </a:r>
-                    </a:p>
-                  </a:txBody>
-                  <a:tcPr anchor="ctr">
+                  <a:tcPr marL="7620" marR="7620" marT="7620" marB="0" anchor="b"/>
+                </a:tc>
+                <a:tc>
+                  <a:txBody>
+                    <a:bodyPr/>
+                    <a:lstStyle/>
+                    <a:p>
+                      <a:pPr marL="0" algn="ctr" defTabSz="914400" rtl="0" eaLnBrk="1" fontAlgn="b" latinLnBrk="0" hangingPunct="1">
+                        <a:buNone/>
+                      </a:pPr>
+                      <a:r>
+                        <a:rPr lang="en-GB" sz="1800" b="0" kern="1200">
+                          <a:solidFill>
+                            <a:sysClr val="windowText" lastClr="000000"/>
+                          </a:solidFill>
+                          <a:latin typeface="+mn-lt"/>
+                          <a:ea typeface="+mn-ea"/>
+                          <a:cs typeface="+mn-cs"/>
+                        </a:rPr>
+                        <a:t>-</a:t>
+                      </a:r>
+                    </a:p>
+                  </a:txBody>
+                  <a:tcPr marL="7620" marR="7620" marT="7620" marB="0" anchor="b"/>
+                </a:tc>
+                <a:tc>
+                  <a:txBody>
+                    <a:bodyPr/>
+                    <a:lstStyle/>
+                    <a:p>
+                      <a:pPr marL="0" algn="ctr" defTabSz="914400" rtl="0" eaLnBrk="1" fontAlgn="b" latinLnBrk="0" hangingPunct="1">
+                        <a:buNone/>
+                      </a:pPr>
+                      <a:r>
+                        <a:rPr lang="en-GB" sz="1800" b="0" kern="1200">
+                          <a:solidFill>
+                            <a:sysClr val="windowText" lastClr="000000"/>
+                          </a:solidFill>
+                          <a:latin typeface="+mn-lt"/>
+                          <a:ea typeface="+mn-ea"/>
+                          <a:cs typeface="+mn-cs"/>
+                        </a:rPr>
+                        <a:t>Distance between nuc centroid and mitocloud centroid</a:t>
+                      </a:r>
+                    </a:p>
+                  </a:txBody>
+                  <a:tcPr marL="7620" marR="7620" marT="7620" marB="0" anchor="b">
                     <a:solidFill>
                       <a:schemeClr val="bg2">
                         <a:lumMod val="90000"/>
@@ -6129,71 +7546,123 @@
                     <a:bodyPr/>
                     <a:lstStyle/>
                     <a:p>
-                      <a:pPr algn="ctr"/>
-                      <a:r>
-                        <a:rPr lang="en-GB" sz="1500" b="0" dirty="0" err="1"/>
+                      <a:pPr marL="0" algn="ctr" defTabSz="914400" rtl="0" eaLnBrk="1" fontAlgn="b" latinLnBrk="0" hangingPunct="1">
+                        <a:buNone/>
+                      </a:pPr>
+                      <a:r>
+                        <a:rPr lang="en-GB" sz="1800" b="0" kern="1200" dirty="0" err="1">
+                          <a:solidFill>
+                            <a:sysClr val="windowText" lastClr="000000"/>
+                          </a:solidFill>
+                          <a:latin typeface="+mn-lt"/>
+                          <a:ea typeface="+mn-ea"/>
+                          <a:cs typeface="+mn-cs"/>
+                        </a:rPr>
                         <a:t>mito_volume_mean</a:t>
                       </a:r>
-                      <a:endParaRPr lang="en-GB" sz="1500" b="0" dirty="0"/>
-                    </a:p>
-                  </a:txBody>
-                  <a:tcPr anchor="ctr"/>
-                </a:tc>
-                <a:tc>
-                  <a:txBody>
-                    <a:bodyPr/>
-                    <a:lstStyle/>
-                    <a:p>
-                      <a:pPr algn="ctr"/>
-                      <a:r>
-                        <a:rPr lang="en-GB" sz="1500" b="0" dirty="0"/>
+                      <a:endParaRPr lang="en-GB" sz="1800" b="0" kern="1200" dirty="0">
+                        <a:solidFill>
+                          <a:sysClr val="windowText" lastClr="000000"/>
+                        </a:solidFill>
+                        <a:latin typeface="+mn-lt"/>
+                        <a:ea typeface="+mn-ea"/>
+                        <a:cs typeface="+mn-cs"/>
+                      </a:endParaRPr>
+                    </a:p>
+                  </a:txBody>
+                  <a:tcPr marL="7620" marR="7620" marT="7620" marB="0" anchor="b"/>
+                </a:tc>
+                <a:tc>
+                  <a:txBody>
+                    <a:bodyPr/>
+                    <a:lstStyle/>
+                    <a:p>
+                      <a:pPr marL="0" algn="ctr" defTabSz="914400" rtl="0" eaLnBrk="1" fontAlgn="b" latinLnBrk="0" hangingPunct="1">
+                        <a:buNone/>
+                      </a:pPr>
+                      <a:r>
+                        <a:rPr lang="en-GB" sz="1800" b="0" kern="1200">
+                          <a:solidFill>
+                            <a:sysClr val="windowText" lastClr="000000"/>
+                          </a:solidFill>
+                          <a:latin typeface="+mn-lt"/>
+                          <a:ea typeface="+mn-ea"/>
+                          <a:cs typeface="+mn-cs"/>
+                        </a:rPr>
                         <a:t>-3.11</a:t>
                       </a:r>
                     </a:p>
                   </a:txBody>
-                  <a:tcPr anchor="ctr"/>
-                </a:tc>
-                <a:tc>
-                  <a:txBody>
-                    <a:bodyPr/>
-                    <a:lstStyle/>
-                    <a:p>
-                      <a:pPr algn="ctr"/>
-                      <a:r>
-                        <a:rPr lang="en-GB" sz="1500" b="0" dirty="0"/>
-                        <a:t>mito_volume_mean</a:t>
-                      </a:r>
-                    </a:p>
-                  </a:txBody>
-                  <a:tcPr anchor="ctr"/>
-                </a:tc>
-                <a:tc>
-                  <a:txBody>
-                    <a:bodyPr/>
-                    <a:lstStyle/>
-                    <a:p>
-                      <a:pPr algn="ctr"/>
-                      <a:r>
-                        <a:rPr lang="en-GB" sz="1500" b="0" dirty="0"/>
+                  <a:tcPr marL="7620" marR="7620" marT="7620" marB="0" anchor="b"/>
+                </a:tc>
+                <a:tc>
+                  <a:txBody>
+                    <a:bodyPr/>
+                    <a:lstStyle/>
+                    <a:p>
+                      <a:pPr marL="0" algn="ctr" defTabSz="914400" rtl="0" eaLnBrk="1" fontAlgn="b" latinLnBrk="0" hangingPunct="1">
+                        <a:buNone/>
+                      </a:pPr>
+                      <a:r>
+                        <a:rPr lang="en-GB" sz="1800" b="0" kern="1200" dirty="0">
+                          <a:solidFill>
+                            <a:sysClr val="windowText" lastClr="000000"/>
+                          </a:solidFill>
+                          <a:latin typeface="+mn-lt"/>
+                          <a:ea typeface="+mn-ea"/>
+                          <a:cs typeface="+mn-cs"/>
+                        </a:rPr>
                         <a:t>-2.55</a:t>
                       </a:r>
                     </a:p>
                   </a:txBody>
-                  <a:tcPr anchor="ctr"/>
-                </a:tc>
-                <a:tc>
-                  <a:txBody>
-                    <a:bodyPr/>
-                    <a:lstStyle/>
-                    <a:p>
-                      <a:pPr algn="ctr"/>
-                      <a:r>
-                        <a:rPr lang="en-GB" sz="1500" b="0" dirty="0"/>
+                  <a:tcPr marL="7620" marR="7620" marT="7620" marB="0" anchor="b"/>
+                </a:tc>
+                <a:tc>
+                  <a:txBody>
+                    <a:bodyPr/>
+                    <a:lstStyle/>
+                    <a:p>
+                      <a:pPr marL="0" algn="ctr" defTabSz="914400" rtl="0" eaLnBrk="1" fontAlgn="b" latinLnBrk="0" hangingPunct="1">
+                        <a:buNone/>
+                      </a:pPr>
+                      <a:r>
+                        <a:rPr lang="en-GB" sz="1800" b="0" kern="1200" dirty="0">
+                          <a:solidFill>
+                            <a:sysClr val="windowText" lastClr="000000"/>
+                          </a:solidFill>
+                          <a:latin typeface="+mn-lt"/>
+                          <a:ea typeface="+mn-ea"/>
+                          <a:cs typeface="+mn-cs"/>
+                        </a:rPr>
+                        <a:t>-</a:t>
+                      </a:r>
+                    </a:p>
+                  </a:txBody>
+                  <a:tcPr marL="7620" marR="7620" marT="7620" marB="0" anchor="b"/>
+                </a:tc>
+                <a:tc>
+                  <a:txBody>
+                    <a:bodyPr/>
+                    <a:lstStyle/>
+                    <a:p>
+                      <a:pPr marL="0" algn="ctr" defTabSz="914400" rtl="0" eaLnBrk="1" fontAlgn="b" latinLnBrk="0" hangingPunct="1">
+                        <a:buNone/>
+                      </a:pPr>
+                      <a:r>
+                        <a:rPr lang="en-GB" sz="1800" b="0" kern="1200" dirty="0">
+                          <a:solidFill>
+                            <a:sysClr val="windowText" lastClr="000000"/>
+                          </a:solidFill>
+                          <a:latin typeface="+mn-lt"/>
+                          <a:ea typeface="+mn-ea"/>
+                          <a:cs typeface="+mn-cs"/>
+                        </a:rPr>
                         <a:t>Mean volume of mitochondria</a:t>
                       </a:r>
                     </a:p>
                   </a:txBody>
-                  <a:tcPr anchor="ctr">
+                  <a:tcPr marL="7620" marR="7620" marT="7620" marB="0" anchor="b">
                     <a:solidFill>
                       <a:schemeClr val="bg2"/>
                     </a:solidFill>
@@ -6211,65 +7680,123 @@
                     <a:bodyPr/>
                     <a:lstStyle/>
                     <a:p>
-                      <a:pPr algn="ctr"/>
-                      <a:endParaRPr lang="en-GB" sz="1500" b="0" dirty="0"/>
-                    </a:p>
-                  </a:txBody>
-                  <a:tcPr anchor="ctr"/>
-                </a:tc>
-                <a:tc>
-                  <a:txBody>
-                    <a:bodyPr/>
-                    <a:lstStyle/>
-                    <a:p>
-                      <a:pPr algn="ctr"/>
-                      <a:endParaRPr lang="en-GB" sz="1500" b="0" dirty="0"/>
-                    </a:p>
-                  </a:txBody>
-                  <a:tcPr anchor="ctr"/>
-                </a:tc>
-                <a:tc>
-                  <a:txBody>
-                    <a:bodyPr/>
-                    <a:lstStyle/>
-                    <a:p>
-                      <a:pPr algn="ctr"/>
-                      <a:r>
-                        <a:rPr lang="en-GB" sz="1500" b="0" dirty="0" err="1"/>
+                      <a:pPr marL="0" algn="ctr" defTabSz="914400" rtl="0" eaLnBrk="1" fontAlgn="b" latinLnBrk="0" hangingPunct="1">
+                        <a:buNone/>
+                      </a:pPr>
+                      <a:r>
+                        <a:rPr lang="en-GB" sz="1800" b="0" kern="1200" dirty="0" err="1">
+                          <a:solidFill>
+                            <a:sysClr val="windowText" lastClr="000000"/>
+                          </a:solidFill>
+                          <a:latin typeface="+mn-lt"/>
+                          <a:ea typeface="+mn-ea"/>
+                          <a:cs typeface="+mn-cs"/>
+                        </a:rPr>
                         <a:t>mito_volume_total</a:t>
                       </a:r>
-                      <a:endParaRPr lang="en-GB" sz="1500" b="0" dirty="0"/>
-                    </a:p>
-                  </a:txBody>
-                  <a:tcPr anchor="ctr"/>
-                </a:tc>
-                <a:tc>
-                  <a:txBody>
-                    <a:bodyPr/>
-                    <a:lstStyle/>
-                    <a:p>
-                      <a:pPr algn="ctr"/>
-                      <a:r>
-                        <a:rPr lang="en-GB" sz="1500" b="0" dirty="0"/>
+                      <a:endParaRPr lang="en-GB" sz="1800" b="0" kern="1200" dirty="0">
+                        <a:solidFill>
+                          <a:sysClr val="windowText" lastClr="000000"/>
+                        </a:solidFill>
+                        <a:latin typeface="+mn-lt"/>
+                        <a:ea typeface="+mn-ea"/>
+                        <a:cs typeface="+mn-cs"/>
+                      </a:endParaRPr>
+                    </a:p>
+                  </a:txBody>
+                  <a:tcPr marL="7620" marR="7620" marT="7620" marB="0" anchor="b"/>
+                </a:tc>
+                <a:tc>
+                  <a:txBody>
+                    <a:bodyPr/>
+                    <a:lstStyle/>
+                    <a:p>
+                      <a:pPr marL="0" algn="ctr" defTabSz="914400" rtl="0" eaLnBrk="1" fontAlgn="b" latinLnBrk="0" hangingPunct="1">
+                        <a:buNone/>
+                      </a:pPr>
+                      <a:r>
+                        <a:rPr lang="en-GB" sz="1800" b="0" kern="1200">
+                          <a:solidFill>
+                            <a:sysClr val="windowText" lastClr="000000"/>
+                          </a:solidFill>
+                          <a:latin typeface="+mn-lt"/>
+                          <a:ea typeface="+mn-ea"/>
+                          <a:cs typeface="+mn-cs"/>
+                        </a:rPr>
+                        <a:t>-</a:t>
+                      </a:r>
+                    </a:p>
+                  </a:txBody>
+                  <a:tcPr marL="7620" marR="7620" marT="7620" marB="0" anchor="b"/>
+                </a:tc>
+                <a:tc>
+                  <a:txBody>
+                    <a:bodyPr/>
+                    <a:lstStyle/>
+                    <a:p>
+                      <a:pPr marL="0" algn="ctr" defTabSz="914400" rtl="0" eaLnBrk="1" fontAlgn="b" latinLnBrk="0" hangingPunct="1">
+                        <a:buNone/>
+                      </a:pPr>
+                      <a:r>
+                        <a:rPr lang="en-GB" sz="1800" b="0" kern="1200" dirty="0">
+                          <a:solidFill>
+                            <a:sysClr val="windowText" lastClr="000000"/>
+                          </a:solidFill>
+                          <a:latin typeface="+mn-lt"/>
+                          <a:ea typeface="+mn-ea"/>
+                          <a:cs typeface="+mn-cs"/>
+                        </a:rPr>
                         <a:t>-2.55</a:t>
                       </a:r>
                     </a:p>
                   </a:txBody>
-                  <a:tcPr anchor="ctr"/>
-                </a:tc>
-                <a:tc>
-                  <a:txBody>
-                    <a:bodyPr/>
-                    <a:lstStyle/>
-                    <a:p>
-                      <a:pPr algn="ctr"/>
-                      <a:r>
-                        <a:rPr lang="en-GB" sz="1500" b="0" dirty="0"/>
+                  <a:tcPr marL="7620" marR="7620" marT="7620" marB="0" anchor="b"/>
+                </a:tc>
+                <a:tc>
+                  <a:txBody>
+                    <a:bodyPr/>
+                    <a:lstStyle/>
+                    <a:p>
+                      <a:pPr marL="0" algn="ctr" defTabSz="914400" rtl="0" eaLnBrk="1" fontAlgn="b" latinLnBrk="0" hangingPunct="1">
+                        <a:buNone/>
+                      </a:pPr>
+                      <a:r>
+                        <a:rPr lang="en-GB" sz="1800" b="0" kern="1200">
+                          <a:solidFill>
+                            <a:sysClr val="windowText" lastClr="000000"/>
+                          </a:solidFill>
+                          <a:latin typeface="+mn-lt"/>
+                          <a:ea typeface="+mn-ea"/>
+                          <a:cs typeface="+mn-cs"/>
+                        </a:rPr>
+                        <a:t>-</a:t>
+                      </a:r>
+                    </a:p>
+                  </a:txBody>
+                  <a:tcPr marL="7620" marR="7620" marT="7620" marB="0" anchor="b"/>
+                </a:tc>
+                <a:tc>
+                  <a:txBody>
+                    <a:bodyPr/>
+                    <a:lstStyle/>
+                    <a:p>
+                      <a:pPr marL="0" algn="ctr" defTabSz="914400" rtl="0" eaLnBrk="1" fontAlgn="b" latinLnBrk="0" hangingPunct="1">
+                        <a:buNone/>
+                      </a:pPr>
+                      <a:r>
+                        <a:rPr lang="en-GB" sz="1800" b="0" kern="1200" dirty="0">
+                          <a:solidFill>
+                            <a:sysClr val="windowText" lastClr="000000"/>
+                          </a:solidFill>
+                          <a:latin typeface="+mn-lt"/>
+                          <a:ea typeface="+mn-ea"/>
+                          <a:cs typeface="+mn-cs"/>
+                        </a:rPr>
                         <a:t>Total volume of all mitochondria</a:t>
                       </a:r>
                     </a:p>
                   </a:txBody>
-                  <a:tcPr anchor="ctr">
+                  <a:tcPr marL="7620" marR="7620" marT="7620" marB="0" anchor="b">
                     <a:solidFill>
                       <a:schemeClr val="bg2">
                         <a:lumMod val="90000"/>
@@ -6289,71 +7816,123 @@
                     <a:bodyPr/>
                     <a:lstStyle/>
                     <a:p>
-                      <a:pPr algn="ctr"/>
-                      <a:r>
-                        <a:rPr lang="en-GB" sz="1500" b="1" dirty="0" err="1"/>
+                      <a:pPr marL="0" algn="ctr" defTabSz="914400" rtl="0" eaLnBrk="1" fontAlgn="b" latinLnBrk="0" hangingPunct="1">
+                        <a:buNone/>
+                      </a:pPr>
+                      <a:r>
+                        <a:rPr lang="en-GB" sz="1800" b="1" kern="1200" dirty="0" err="1">
+                          <a:solidFill>
+                            <a:sysClr val="windowText" lastClr="000000"/>
+                          </a:solidFill>
+                          <a:latin typeface="+mn-lt"/>
+                          <a:ea typeface="+mn-ea"/>
+                          <a:cs typeface="+mn-cs"/>
+                        </a:rPr>
                         <a:t>mito_surface_area_mean</a:t>
                       </a:r>
-                      <a:endParaRPr lang="en-GB" sz="1500" b="1" dirty="0"/>
-                    </a:p>
-                  </a:txBody>
-                  <a:tcPr anchor="ctr"/>
-                </a:tc>
-                <a:tc>
-                  <a:txBody>
-                    <a:bodyPr/>
-                    <a:lstStyle/>
-                    <a:p>
-                      <a:pPr algn="ctr"/>
-                      <a:r>
-                        <a:rPr lang="en-GB" sz="1500" b="1" dirty="0"/>
+                      <a:endParaRPr lang="en-GB" sz="1800" b="1" kern="1200" dirty="0">
+                        <a:solidFill>
+                          <a:sysClr val="windowText" lastClr="000000"/>
+                        </a:solidFill>
+                        <a:latin typeface="+mn-lt"/>
+                        <a:ea typeface="+mn-ea"/>
+                        <a:cs typeface="+mn-cs"/>
+                      </a:endParaRPr>
+                    </a:p>
+                  </a:txBody>
+                  <a:tcPr marL="7620" marR="7620" marT="7620" marB="0" anchor="b"/>
+                </a:tc>
+                <a:tc>
+                  <a:txBody>
+                    <a:bodyPr/>
+                    <a:lstStyle/>
+                    <a:p>
+                      <a:pPr marL="0" algn="ctr" defTabSz="914400" rtl="0" eaLnBrk="1" fontAlgn="b" latinLnBrk="0" hangingPunct="1">
+                        <a:buNone/>
+                      </a:pPr>
+                      <a:r>
+                        <a:rPr lang="en-GB" sz="1800" b="1" kern="1200">
+                          <a:solidFill>
+                            <a:sysClr val="windowText" lastClr="000000"/>
+                          </a:solidFill>
+                          <a:latin typeface="+mn-lt"/>
+                          <a:ea typeface="+mn-ea"/>
+                          <a:cs typeface="+mn-cs"/>
+                        </a:rPr>
                         <a:t>-6.65</a:t>
                       </a:r>
                     </a:p>
                   </a:txBody>
-                  <a:tcPr anchor="ctr"/>
-                </a:tc>
-                <a:tc>
-                  <a:txBody>
-                    <a:bodyPr/>
-                    <a:lstStyle/>
-                    <a:p>
-                      <a:pPr algn="ctr"/>
-                      <a:r>
-                        <a:rPr lang="en-GB" sz="1500" b="1" dirty="0"/>
-                        <a:t>mito_surface_area_mean</a:t>
-                      </a:r>
-                    </a:p>
-                  </a:txBody>
-                  <a:tcPr anchor="ctr"/>
-                </a:tc>
-                <a:tc>
-                  <a:txBody>
-                    <a:bodyPr/>
-                    <a:lstStyle/>
-                    <a:p>
-                      <a:pPr algn="ctr"/>
-                      <a:r>
-                        <a:rPr lang="en-GB" sz="1500" b="1" dirty="0"/>
+                  <a:tcPr marL="7620" marR="7620" marT="7620" marB="0" anchor="b"/>
+                </a:tc>
+                <a:tc>
+                  <a:txBody>
+                    <a:bodyPr/>
+                    <a:lstStyle/>
+                    <a:p>
+                      <a:pPr marL="0" algn="ctr" defTabSz="914400" rtl="0" eaLnBrk="1" fontAlgn="b" latinLnBrk="0" hangingPunct="1">
+                        <a:buNone/>
+                      </a:pPr>
+                      <a:r>
+                        <a:rPr lang="en-GB" sz="1800" b="1" kern="1200" dirty="0">
+                          <a:solidFill>
+                            <a:sysClr val="windowText" lastClr="000000"/>
+                          </a:solidFill>
+                          <a:latin typeface="+mn-lt"/>
+                          <a:ea typeface="+mn-ea"/>
+                          <a:cs typeface="+mn-cs"/>
+                        </a:rPr>
                         <a:t>-6.14</a:t>
                       </a:r>
                     </a:p>
                   </a:txBody>
-                  <a:tcPr anchor="ctr"/>
-                </a:tc>
-                <a:tc>
-                  <a:txBody>
-                    <a:bodyPr/>
-                    <a:lstStyle/>
-                    <a:p>
-                      <a:pPr algn="ctr"/>
-                      <a:r>
-                        <a:rPr lang="en-GB" sz="1500" b="0" dirty="0"/>
+                  <a:tcPr marL="7620" marR="7620" marT="7620" marB="0" anchor="b"/>
+                </a:tc>
+                <a:tc>
+                  <a:txBody>
+                    <a:bodyPr/>
+                    <a:lstStyle/>
+                    <a:p>
+                      <a:pPr marL="0" algn="ctr" defTabSz="914400" rtl="0" eaLnBrk="1" fontAlgn="b" latinLnBrk="0" hangingPunct="1">
+                        <a:buNone/>
+                      </a:pPr>
+                      <a:r>
+                        <a:rPr lang="en-GB" sz="1800" b="1" kern="1200">
+                          <a:solidFill>
+                            <a:sysClr val="windowText" lastClr="000000"/>
+                          </a:solidFill>
+                          <a:latin typeface="+mn-lt"/>
+                          <a:ea typeface="+mn-ea"/>
+                          <a:cs typeface="+mn-cs"/>
+                        </a:rPr>
+                        <a:t>-3.62</a:t>
+                      </a:r>
+                    </a:p>
+                  </a:txBody>
+                  <a:tcPr marL="7620" marR="7620" marT="7620" marB="0" anchor="b"/>
+                </a:tc>
+                <a:tc>
+                  <a:txBody>
+                    <a:bodyPr/>
+                    <a:lstStyle/>
+                    <a:p>
+                      <a:pPr marL="0" algn="ctr" defTabSz="914400" rtl="0" eaLnBrk="1" fontAlgn="b" latinLnBrk="0" hangingPunct="1">
+                        <a:buNone/>
+                      </a:pPr>
+                      <a:r>
+                        <a:rPr lang="en-GB" sz="1800" b="1" kern="1200" dirty="0">
+                          <a:solidFill>
+                            <a:sysClr val="windowText" lastClr="000000"/>
+                          </a:solidFill>
+                          <a:latin typeface="+mn-lt"/>
+                          <a:ea typeface="+mn-ea"/>
+                          <a:cs typeface="+mn-cs"/>
+                        </a:rPr>
                         <a:t>Mean surf. area of mitochondria</a:t>
                       </a:r>
                     </a:p>
                   </a:txBody>
-                  <a:tcPr anchor="ctr">
+                  <a:tcPr marL="7620" marR="7620" marT="7620" marB="0" anchor="b">
                     <a:solidFill>
                       <a:schemeClr val="bg2"/>
                     </a:solidFill>
@@ -6371,71 +7950,123 @@
                     <a:bodyPr/>
                     <a:lstStyle/>
                     <a:p>
-                      <a:pPr algn="ctr"/>
-                      <a:r>
-                        <a:rPr lang="en-GB" sz="1500" b="1" dirty="0"/>
+                      <a:pPr marL="0" algn="ctr" defTabSz="914400" rtl="0" eaLnBrk="1" fontAlgn="b" latinLnBrk="0" hangingPunct="1">
+                        <a:buNone/>
+                      </a:pPr>
+                      <a:r>
+                        <a:rPr lang="en-GB" sz="1800" b="1" kern="1200" dirty="0" err="1">
+                          <a:solidFill>
+                            <a:sysClr val="windowText" lastClr="000000"/>
+                          </a:solidFill>
+                          <a:latin typeface="+mn-lt"/>
+                          <a:ea typeface="+mn-ea"/>
+                          <a:cs typeface="+mn-cs"/>
+                        </a:rPr>
                         <a:t>mito_centroid_distance_mean</a:t>
                       </a:r>
-                    </a:p>
-                  </a:txBody>
-                  <a:tcPr anchor="ctr"/>
-                </a:tc>
-                <a:tc>
-                  <a:txBody>
-                    <a:bodyPr/>
-                    <a:lstStyle/>
-                    <a:p>
-                      <a:pPr algn="ctr"/>
-                      <a:r>
-                        <a:rPr lang="en-GB" sz="1500" b="1" dirty="0"/>
+                      <a:endParaRPr lang="en-GB" sz="1800" b="1" kern="1200" dirty="0">
+                        <a:solidFill>
+                          <a:sysClr val="windowText" lastClr="000000"/>
+                        </a:solidFill>
+                        <a:latin typeface="+mn-lt"/>
+                        <a:ea typeface="+mn-ea"/>
+                        <a:cs typeface="+mn-cs"/>
+                      </a:endParaRPr>
+                    </a:p>
+                  </a:txBody>
+                  <a:tcPr marL="7620" marR="7620" marT="7620" marB="0" anchor="b"/>
+                </a:tc>
+                <a:tc>
+                  <a:txBody>
+                    <a:bodyPr/>
+                    <a:lstStyle/>
+                    <a:p>
+                      <a:pPr marL="0" algn="ctr" defTabSz="914400" rtl="0" eaLnBrk="1" fontAlgn="b" latinLnBrk="0" hangingPunct="1">
+                        <a:buNone/>
+                      </a:pPr>
+                      <a:r>
+                        <a:rPr lang="en-GB" sz="1800" b="1" kern="1200" dirty="0">
+                          <a:solidFill>
+                            <a:sysClr val="windowText" lastClr="000000"/>
+                          </a:solidFill>
+                          <a:latin typeface="+mn-lt"/>
+                          <a:ea typeface="+mn-ea"/>
+                          <a:cs typeface="+mn-cs"/>
+                        </a:rPr>
                         <a:t>4.75</a:t>
                       </a:r>
                     </a:p>
                   </a:txBody>
-                  <a:tcPr anchor="ctr"/>
-                </a:tc>
-                <a:tc>
-                  <a:txBody>
-                    <a:bodyPr/>
-                    <a:lstStyle/>
-                    <a:p>
-                      <a:pPr algn="ctr"/>
-                      <a:r>
-                        <a:rPr lang="en-GB" sz="1500" b="1" dirty="0" err="1"/>
-                        <a:t>mito_centroid_distance_mean</a:t>
-                      </a:r>
-                      <a:endParaRPr lang="en-GB" sz="1500" b="1" dirty="0"/>
-                    </a:p>
-                  </a:txBody>
-                  <a:tcPr anchor="ctr"/>
-                </a:tc>
-                <a:tc>
-                  <a:txBody>
-                    <a:bodyPr/>
-                    <a:lstStyle/>
-                    <a:p>
-                      <a:pPr algn="ctr"/>
-                      <a:r>
-                        <a:rPr lang="en-GB" sz="1500" b="1" dirty="0"/>
+                  <a:tcPr marL="7620" marR="7620" marT="7620" marB="0" anchor="b"/>
+                </a:tc>
+                <a:tc>
+                  <a:txBody>
+                    <a:bodyPr/>
+                    <a:lstStyle/>
+                    <a:p>
+                      <a:pPr marL="0" algn="ctr" defTabSz="914400" rtl="0" eaLnBrk="1" fontAlgn="b" latinLnBrk="0" hangingPunct="1">
+                        <a:buNone/>
+                      </a:pPr>
+                      <a:r>
+                        <a:rPr lang="en-GB" sz="1800" b="1" kern="1200" dirty="0">
+                          <a:solidFill>
+                            <a:sysClr val="windowText" lastClr="000000"/>
+                          </a:solidFill>
+                          <a:latin typeface="+mn-lt"/>
+                          <a:ea typeface="+mn-ea"/>
+                          <a:cs typeface="+mn-cs"/>
+                        </a:rPr>
                         <a:t>4.19</a:t>
                       </a:r>
                     </a:p>
                   </a:txBody>
-                  <a:tcPr anchor="ctr"/>
-                </a:tc>
-                <a:tc>
-                  <a:txBody>
-                    <a:bodyPr/>
-                    <a:lstStyle/>
-                    <a:p>
-                      <a:pPr algn="ctr"/>
-                      <a:r>
-                        <a:rPr lang="en-GB" sz="1500" b="0" dirty="0"/>
+                  <a:tcPr marL="7620" marR="7620" marT="7620" marB="0" anchor="b"/>
+                </a:tc>
+                <a:tc>
+                  <a:txBody>
+                    <a:bodyPr/>
+                    <a:lstStyle/>
+                    <a:p>
+                      <a:pPr marL="0" algn="ctr" defTabSz="914400" rtl="0" eaLnBrk="1" fontAlgn="b" latinLnBrk="0" hangingPunct="1">
+                        <a:buNone/>
+                      </a:pPr>
+                      <a:r>
+                        <a:rPr lang="en-GB" sz="1800" b="1" kern="1200" dirty="0">
+                          <a:solidFill>
+                            <a:sysClr val="windowText" lastClr="000000"/>
+                          </a:solidFill>
+                          <a:latin typeface="+mn-lt"/>
+                          <a:ea typeface="+mn-ea"/>
+                          <a:cs typeface="+mn-cs"/>
+                        </a:rPr>
+                        <a:t>3.00</a:t>
+                      </a:r>
+                    </a:p>
+                  </a:txBody>
+                  <a:tcPr marL="7620" marR="7620" marT="7620" marB="0" anchor="b"/>
+                </a:tc>
+                <a:tc>
+                  <a:txBody>
+                    <a:bodyPr/>
+                    <a:lstStyle/>
+                    <a:p>
+                      <a:pPr marL="0" algn="ctr" defTabSz="914400" rtl="0" eaLnBrk="1" fontAlgn="b" latinLnBrk="0" hangingPunct="1">
+                        <a:buNone/>
+                      </a:pPr>
+                      <a:r>
+                        <a:rPr lang="en-GB" sz="1800" b="1" kern="1200" dirty="0">
+                          <a:solidFill>
+                            <a:sysClr val="windowText" lastClr="000000"/>
+                          </a:solidFill>
+                          <a:latin typeface="+mn-lt"/>
+                          <a:ea typeface="+mn-ea"/>
+                          <a:cs typeface="+mn-cs"/>
+                        </a:rPr>
                         <a:t>Mean mitochondria distance to nucleus centroid</a:t>
                       </a:r>
                     </a:p>
                   </a:txBody>
-                  <a:tcPr anchor="ctr">
+                  <a:tcPr marL="7620" marR="7620" marT="7620" marB="0" anchor="b">
                     <a:solidFill>
                       <a:schemeClr val="bg2">
                         <a:lumMod val="90000"/>
@@ -6455,72 +8086,123 @@
                     <a:bodyPr/>
                     <a:lstStyle/>
                     <a:p>
-                      <a:pPr algn="ctr"/>
-                      <a:r>
-                        <a:rPr lang="en-GB" sz="1500" b="1"/>
+                      <a:pPr marL="0" algn="ctr" defTabSz="914400" rtl="0" eaLnBrk="1" fontAlgn="b" latinLnBrk="0" hangingPunct="1">
+                        <a:buNone/>
+                      </a:pPr>
+                      <a:r>
+                        <a:rPr lang="en-GB" sz="1800" b="1" kern="1200" dirty="0" err="1">
+                          <a:solidFill>
+                            <a:sysClr val="windowText" lastClr="000000"/>
+                          </a:solidFill>
+                          <a:latin typeface="+mn-lt"/>
+                          <a:ea typeface="+mn-ea"/>
+                          <a:cs typeface="+mn-cs"/>
+                        </a:rPr>
                         <a:t>mito_surface_distance_mean</a:t>
                       </a:r>
-                      <a:endParaRPr lang="en-GB" sz="1500" b="1" dirty="0"/>
-                    </a:p>
-                  </a:txBody>
-                  <a:tcPr anchor="ctr"/>
-                </a:tc>
-                <a:tc>
-                  <a:txBody>
-                    <a:bodyPr/>
-                    <a:lstStyle/>
-                    <a:p>
-                      <a:pPr algn="ctr"/>
-                      <a:r>
-                        <a:rPr lang="en-GB" sz="1500" b="1" dirty="0"/>
+                      <a:endParaRPr lang="en-GB" sz="1800" b="1" kern="1200" dirty="0">
+                        <a:solidFill>
+                          <a:sysClr val="windowText" lastClr="000000"/>
+                        </a:solidFill>
+                        <a:latin typeface="+mn-lt"/>
+                        <a:ea typeface="+mn-ea"/>
+                        <a:cs typeface="+mn-cs"/>
+                      </a:endParaRPr>
+                    </a:p>
+                  </a:txBody>
+                  <a:tcPr marL="7620" marR="7620" marT="7620" marB="0" anchor="b"/>
+                </a:tc>
+                <a:tc>
+                  <a:txBody>
+                    <a:bodyPr/>
+                    <a:lstStyle/>
+                    <a:p>
+                      <a:pPr marL="0" algn="ctr" defTabSz="914400" rtl="0" eaLnBrk="1" fontAlgn="b" latinLnBrk="0" hangingPunct="1">
+                        <a:buNone/>
+                      </a:pPr>
+                      <a:r>
+                        <a:rPr lang="en-GB" sz="1800" b="1" kern="1200">
+                          <a:solidFill>
+                            <a:sysClr val="windowText" lastClr="000000"/>
+                          </a:solidFill>
+                          <a:latin typeface="+mn-lt"/>
+                          <a:ea typeface="+mn-ea"/>
+                          <a:cs typeface="+mn-cs"/>
+                        </a:rPr>
                         <a:t>3.86</a:t>
                       </a:r>
                     </a:p>
                   </a:txBody>
-                  <a:tcPr anchor="ctr"/>
-                </a:tc>
-                <a:tc>
-                  <a:txBody>
-                    <a:bodyPr/>
-                    <a:lstStyle/>
-                    <a:p>
-                      <a:pPr algn="ctr"/>
-                      <a:r>
-                        <a:rPr lang="en-GB" sz="1500" b="1" dirty="0" err="1"/>
-                        <a:t>mito_surface_distance_mean</a:t>
-                      </a:r>
-                      <a:endParaRPr lang="en-GB" sz="1500" b="1" dirty="0"/>
-                    </a:p>
-                  </a:txBody>
-                  <a:tcPr anchor="ctr"/>
-                </a:tc>
-                <a:tc>
-                  <a:txBody>
-                    <a:bodyPr/>
-                    <a:lstStyle/>
-                    <a:p>
-                      <a:pPr algn="ctr"/>
-                      <a:r>
-                        <a:rPr lang="en-GB" sz="1500" b="1" dirty="0"/>
+                  <a:tcPr marL="7620" marR="7620" marT="7620" marB="0" anchor="b"/>
+                </a:tc>
+                <a:tc>
+                  <a:txBody>
+                    <a:bodyPr/>
+                    <a:lstStyle/>
+                    <a:p>
+                      <a:pPr marL="0" algn="ctr" defTabSz="914400" rtl="0" eaLnBrk="1" fontAlgn="b" latinLnBrk="0" hangingPunct="1">
+                        <a:buNone/>
+                      </a:pPr>
+                      <a:r>
+                        <a:rPr lang="en-GB" sz="1800" b="1" kern="1200" dirty="0">
+                          <a:solidFill>
+                            <a:sysClr val="windowText" lastClr="000000"/>
+                          </a:solidFill>
+                          <a:latin typeface="+mn-lt"/>
+                          <a:ea typeface="+mn-ea"/>
+                          <a:cs typeface="+mn-cs"/>
+                        </a:rPr>
                         <a:t>4.39</a:t>
                       </a:r>
                     </a:p>
                   </a:txBody>
-                  <a:tcPr anchor="ctr"/>
-                </a:tc>
-                <a:tc>
-                  <a:txBody>
-                    <a:bodyPr/>
-                    <a:lstStyle/>
-                    <a:p>
-                      <a:pPr algn="ctr"/>
-                      <a:r>
-                        <a:rPr lang="en-GB" sz="1500" b="0" dirty="0"/>
+                  <a:tcPr marL="7620" marR="7620" marT="7620" marB="0" anchor="b"/>
+                </a:tc>
+                <a:tc>
+                  <a:txBody>
+                    <a:bodyPr/>
+                    <a:lstStyle/>
+                    <a:p>
+                      <a:pPr marL="0" algn="ctr" defTabSz="914400" rtl="0" eaLnBrk="1" fontAlgn="b" latinLnBrk="0" hangingPunct="1">
+                        <a:buNone/>
+                      </a:pPr>
+                      <a:r>
+                        <a:rPr lang="en-GB" sz="1800" b="1" kern="1200" dirty="0">
+                          <a:solidFill>
+                            <a:sysClr val="windowText" lastClr="000000"/>
+                          </a:solidFill>
+                          <a:latin typeface="+mn-lt"/>
+                          <a:ea typeface="+mn-ea"/>
+                          <a:cs typeface="+mn-cs"/>
+                        </a:rPr>
+                        <a:t>-</a:t>
+                      </a:r>
+                    </a:p>
+                  </a:txBody>
+                  <a:tcPr marL="7620" marR="7620" marT="7620" marB="0" anchor="b"/>
+                </a:tc>
+                <a:tc>
+                  <a:txBody>
+                    <a:bodyPr/>
+                    <a:lstStyle/>
+                    <a:p>
+                      <a:pPr marL="0" algn="ctr" defTabSz="914400" rtl="0" eaLnBrk="1" fontAlgn="b" latinLnBrk="0" hangingPunct="1">
+                        <a:buNone/>
+                      </a:pPr>
+                      <a:r>
+                        <a:rPr lang="en-GB" sz="1800" b="1" kern="1200" dirty="0">
+                          <a:solidFill>
+                            <a:sysClr val="windowText" lastClr="000000"/>
+                          </a:solidFill>
+                          <a:latin typeface="+mn-lt"/>
+                          <a:ea typeface="+mn-ea"/>
+                          <a:cs typeface="+mn-cs"/>
+                        </a:rPr>
                         <a:t>Mean mitochondria distance to nucleus surface</a:t>
                       </a:r>
                     </a:p>
                   </a:txBody>
-                  <a:tcPr anchor="ctr">
+                  <a:tcPr marL="7620" marR="7620" marT="7620" marB="0" anchor="b">
                     <a:solidFill>
                       <a:schemeClr val="bg2"/>
                     </a:solidFill>
@@ -6538,71 +8220,123 @@
                     <a:bodyPr/>
                     <a:lstStyle/>
                     <a:p>
-                      <a:pPr algn="ctr"/>
-                      <a:r>
-                        <a:rPr lang="en-GB" sz="1500" b="0" dirty="0"/>
+                      <a:pPr marL="0" algn="ctr" defTabSz="914400" rtl="0" eaLnBrk="1" fontAlgn="b" latinLnBrk="0" hangingPunct="1">
+                        <a:buNone/>
+                      </a:pPr>
+                      <a:r>
+                        <a:rPr lang="en-GB" sz="1800" b="0" kern="1200" dirty="0" err="1">
+                          <a:solidFill>
+                            <a:sysClr val="windowText" lastClr="000000"/>
+                          </a:solidFill>
+                          <a:latin typeface="+mn-lt"/>
+                          <a:ea typeface="+mn-ea"/>
+                          <a:cs typeface="+mn-cs"/>
+                        </a:rPr>
                         <a:t>mito_volume_fraction</a:t>
                       </a:r>
-                    </a:p>
-                  </a:txBody>
-                  <a:tcPr anchor="ctr"/>
-                </a:tc>
-                <a:tc>
-                  <a:txBody>
-                    <a:bodyPr/>
-                    <a:lstStyle/>
-                    <a:p>
-                      <a:pPr algn="ctr"/>
-                      <a:r>
-                        <a:rPr lang="en-GB" sz="1500" b="0" dirty="0"/>
+                      <a:endParaRPr lang="en-GB" sz="1800" b="0" kern="1200" dirty="0">
+                        <a:solidFill>
+                          <a:sysClr val="windowText" lastClr="000000"/>
+                        </a:solidFill>
+                        <a:latin typeface="+mn-lt"/>
+                        <a:ea typeface="+mn-ea"/>
+                        <a:cs typeface="+mn-cs"/>
+                      </a:endParaRPr>
+                    </a:p>
+                  </a:txBody>
+                  <a:tcPr marL="7620" marR="7620" marT="7620" marB="0" anchor="b"/>
+                </a:tc>
+                <a:tc>
+                  <a:txBody>
+                    <a:bodyPr/>
+                    <a:lstStyle/>
+                    <a:p>
+                      <a:pPr marL="0" algn="ctr" defTabSz="914400" rtl="0" eaLnBrk="1" fontAlgn="b" latinLnBrk="0" hangingPunct="1">
+                        <a:buNone/>
+                      </a:pPr>
+                      <a:r>
+                        <a:rPr lang="en-GB" sz="1800" b="0" kern="1200" dirty="0">
+                          <a:solidFill>
+                            <a:sysClr val="windowText" lastClr="000000"/>
+                          </a:solidFill>
+                          <a:latin typeface="+mn-lt"/>
+                          <a:ea typeface="+mn-ea"/>
+                          <a:cs typeface="+mn-cs"/>
+                        </a:rPr>
                         <a:t>-3.27</a:t>
                       </a:r>
                     </a:p>
                   </a:txBody>
-                  <a:tcPr anchor="ctr"/>
-                </a:tc>
-                <a:tc>
-                  <a:txBody>
-                    <a:bodyPr/>
-                    <a:lstStyle/>
-                    <a:p>
-                      <a:pPr algn="ctr"/>
-                      <a:r>
-                        <a:rPr lang="en-GB" sz="1500" b="0" dirty="0" err="1"/>
-                        <a:t>mito_volume_fraction</a:t>
-                      </a:r>
-                      <a:endParaRPr lang="en-GB" sz="1500" b="0" dirty="0"/>
-                    </a:p>
-                  </a:txBody>
-                  <a:tcPr anchor="ctr"/>
-                </a:tc>
-                <a:tc>
-                  <a:txBody>
-                    <a:bodyPr/>
-                    <a:lstStyle/>
-                    <a:p>
-                      <a:pPr algn="ctr"/>
-                      <a:r>
-                        <a:rPr lang="en-GB" sz="1500" b="0" dirty="0"/>
+                  <a:tcPr marL="7620" marR="7620" marT="7620" marB="0" anchor="b"/>
+                </a:tc>
+                <a:tc>
+                  <a:txBody>
+                    <a:bodyPr/>
+                    <a:lstStyle/>
+                    <a:p>
+                      <a:pPr marL="0" algn="ctr" defTabSz="914400" rtl="0" eaLnBrk="1" fontAlgn="b" latinLnBrk="0" hangingPunct="1">
+                        <a:buNone/>
+                      </a:pPr>
+                      <a:r>
+                        <a:rPr lang="en-GB" sz="1800" b="0" kern="1200">
+                          <a:solidFill>
+                            <a:sysClr val="windowText" lastClr="000000"/>
+                          </a:solidFill>
+                          <a:latin typeface="+mn-lt"/>
+                          <a:ea typeface="+mn-ea"/>
+                          <a:cs typeface="+mn-cs"/>
+                        </a:rPr>
                         <a:t>-3.53</a:t>
                       </a:r>
                     </a:p>
                   </a:txBody>
-                  <a:tcPr anchor="ctr"/>
-                </a:tc>
-                <a:tc>
-                  <a:txBody>
-                    <a:bodyPr/>
-                    <a:lstStyle/>
-                    <a:p>
-                      <a:pPr algn="ctr"/>
-                      <a:r>
-                        <a:rPr lang="en-GB" sz="1500" b="0" dirty="0"/>
+                  <a:tcPr marL="7620" marR="7620" marT="7620" marB="0" anchor="b"/>
+                </a:tc>
+                <a:tc>
+                  <a:txBody>
+                    <a:bodyPr/>
+                    <a:lstStyle/>
+                    <a:p>
+                      <a:pPr marL="0" algn="ctr" defTabSz="914400" rtl="0" eaLnBrk="1" fontAlgn="b" latinLnBrk="0" hangingPunct="1">
+                        <a:buNone/>
+                      </a:pPr>
+                      <a:r>
+                        <a:rPr lang="en-GB" sz="1800" b="0" kern="1200" dirty="0">
+                          <a:solidFill>
+                            <a:sysClr val="windowText" lastClr="000000"/>
+                          </a:solidFill>
+                          <a:latin typeface="+mn-lt"/>
+                          <a:ea typeface="+mn-ea"/>
+                          <a:cs typeface="+mn-cs"/>
+                        </a:rPr>
+                        <a:t>-</a:t>
+                      </a:r>
+                    </a:p>
+                  </a:txBody>
+                  <a:tcPr marL="7620" marR="7620" marT="7620" marB="0" anchor="b"/>
+                </a:tc>
+                <a:tc>
+                  <a:txBody>
+                    <a:bodyPr/>
+                    <a:lstStyle/>
+                    <a:p>
+                      <a:pPr marL="0" algn="ctr" defTabSz="914400" rtl="0" eaLnBrk="1" fontAlgn="b" latinLnBrk="0" hangingPunct="1">
+                        <a:buNone/>
+                      </a:pPr>
+                      <a:r>
+                        <a:rPr lang="en-GB" sz="1800" b="0" kern="1200" dirty="0">
+                          <a:solidFill>
+                            <a:sysClr val="windowText" lastClr="000000"/>
+                          </a:solidFill>
+                          <a:latin typeface="+mn-lt"/>
+                          <a:ea typeface="+mn-ea"/>
+                          <a:cs typeface="+mn-cs"/>
+                        </a:rPr>
                         <a:t>Ratio of mitochondrial volume to nuclear volume</a:t>
                       </a:r>
                     </a:p>
                   </a:txBody>
-                  <a:tcPr anchor="ctr">
+                  <a:tcPr marL="7620" marR="7620" marT="7620" marB="0" anchor="b">
                     <a:solidFill>
                       <a:schemeClr val="bg2">
                         <a:lumMod val="90000"/>
@@ -6623,7 +8357,7 @@
     </p:spTree>
     <p:extLst>
       <p:ext uri="{BB962C8B-B14F-4D97-AF65-F5344CB8AC3E}">
-        <p14:creationId xmlns:p14="http://schemas.microsoft.com/office/powerpoint/2010/main" val="4292883916"/>
+        <p14:creationId xmlns:p14="http://schemas.microsoft.com/office/powerpoint/2010/main" val="1515460260"/>
       </p:ext>
     </p:extLst>
   </p:cSld>

</xml_diff>